<commit_message>
Add workshop repository QR to slides
</commit_message>
<xml_diff>
--- a/slides/google-adk-voice-agents-workshop.pptx
+++ b/slides/google-adk-voice-agents-workshop.pptx
@@ -2,30 +2,30 @@
 <file path=ppt/presentation.xml><?xml version="1.0" encoding="utf-8"?>
 <p:presentation xmlns:p="http://schemas.openxmlformats.org/presentationml/2006/main">
   <p:sldMasterIdLst>
-    <p:sldMasterId xmlns:r="http://schemas.openxmlformats.org/officeDocument/2006/relationships" id="2147483648" r:id="Re3526cd7d3924f35"/>
+    <p:sldMasterId xmlns:r="http://schemas.openxmlformats.org/officeDocument/2006/relationships" id="2147483648" r:id="R56ca2458ce794941"/>
   </p:sldMasterIdLst>
   <p:notesMasterIdLst>
-    <p:notesMasterId xmlns:r="http://schemas.openxmlformats.org/officeDocument/2006/relationships" r:id="R6efdc9e72e5d4f59"/>
+    <p:notesMasterId xmlns:r="http://schemas.openxmlformats.org/officeDocument/2006/relationships" r:id="Rd772345d9f2446c1"/>
   </p:notesMasterIdLst>
   <p:sldIdLst>
-    <p:sldId xmlns:r="http://schemas.openxmlformats.org/officeDocument/2006/relationships" id="256" r:id="Rea8394cd56c64ec1"/>
-    <p:sldId xmlns:r="http://schemas.openxmlformats.org/officeDocument/2006/relationships" id="257" r:id="R2369b88d480f44fd"/>
-    <p:sldId xmlns:r="http://schemas.openxmlformats.org/officeDocument/2006/relationships" id="258" r:id="R9e01f23fd64b4f3e"/>
-    <p:sldId xmlns:r="http://schemas.openxmlformats.org/officeDocument/2006/relationships" id="259" r:id="R0fb6e4a4bebc47cb"/>
-    <p:sldId xmlns:r="http://schemas.openxmlformats.org/officeDocument/2006/relationships" id="260" r:id="Rbdd152db2c0d4202"/>
-    <p:sldId xmlns:r="http://schemas.openxmlformats.org/officeDocument/2006/relationships" id="261" r:id="R308297f5f1b843e9"/>
-    <p:sldId xmlns:r="http://schemas.openxmlformats.org/officeDocument/2006/relationships" id="262" r:id="R129ab4eac43e442d"/>
-    <p:sldId xmlns:r="http://schemas.openxmlformats.org/officeDocument/2006/relationships" id="263" r:id="R97d70354e00f4eb5"/>
-    <p:sldId xmlns:r="http://schemas.openxmlformats.org/officeDocument/2006/relationships" id="264" r:id="R3f074fa3a18c4a7e"/>
-    <p:sldId xmlns:r="http://schemas.openxmlformats.org/officeDocument/2006/relationships" id="265" r:id="Reea555c1f00b4b53"/>
-    <p:sldId xmlns:r="http://schemas.openxmlformats.org/officeDocument/2006/relationships" id="266" r:id="R10bb91c9d6b140b4"/>
-    <p:sldId xmlns:r="http://schemas.openxmlformats.org/officeDocument/2006/relationships" id="267" r:id="Rb47e5f1810d24e1a"/>
-    <p:sldId xmlns:r="http://schemas.openxmlformats.org/officeDocument/2006/relationships" id="268" r:id="R6e9c29037c624bd2"/>
-    <p:sldId xmlns:r="http://schemas.openxmlformats.org/officeDocument/2006/relationships" id="269" r:id="Rdf82a794a4b34cae"/>
-    <p:sldId xmlns:r="http://schemas.openxmlformats.org/officeDocument/2006/relationships" id="270" r:id="R1b76e8f528e24504"/>
-    <p:sldId xmlns:r="http://schemas.openxmlformats.org/officeDocument/2006/relationships" id="271" r:id="R6a3c8dd17df54ad8"/>
-    <p:sldId xmlns:r="http://schemas.openxmlformats.org/officeDocument/2006/relationships" id="272" r:id="R779f149dbaa34d48"/>
-    <p:sldId xmlns:r="http://schemas.openxmlformats.org/officeDocument/2006/relationships" id="273" r:id="Rf7860e716ee94217"/>
+    <p:sldId xmlns:r="http://schemas.openxmlformats.org/officeDocument/2006/relationships" id="256" r:id="R6463ea99a05c4e4c"/>
+    <p:sldId xmlns:r="http://schemas.openxmlformats.org/officeDocument/2006/relationships" id="257" r:id="R0964bc063c904b43"/>
+    <p:sldId xmlns:r="http://schemas.openxmlformats.org/officeDocument/2006/relationships" id="258" r:id="Ref1f2d2bb9bc4725"/>
+    <p:sldId xmlns:r="http://schemas.openxmlformats.org/officeDocument/2006/relationships" id="259" r:id="R03d1c9713f8a48ff"/>
+    <p:sldId xmlns:r="http://schemas.openxmlformats.org/officeDocument/2006/relationships" id="260" r:id="R82466c59ed0d47ca"/>
+    <p:sldId xmlns:r="http://schemas.openxmlformats.org/officeDocument/2006/relationships" id="261" r:id="Rb9306da1a28043ad"/>
+    <p:sldId xmlns:r="http://schemas.openxmlformats.org/officeDocument/2006/relationships" id="262" r:id="Rf08433a980c3456c"/>
+    <p:sldId xmlns:r="http://schemas.openxmlformats.org/officeDocument/2006/relationships" id="263" r:id="Rba28c1e09ad44056"/>
+    <p:sldId xmlns:r="http://schemas.openxmlformats.org/officeDocument/2006/relationships" id="264" r:id="R19e850bedfe440cd"/>
+    <p:sldId xmlns:r="http://schemas.openxmlformats.org/officeDocument/2006/relationships" id="265" r:id="R2540675fffbe4a79"/>
+    <p:sldId xmlns:r="http://schemas.openxmlformats.org/officeDocument/2006/relationships" id="266" r:id="R43ab2b4fea9e4073"/>
+    <p:sldId xmlns:r="http://schemas.openxmlformats.org/officeDocument/2006/relationships" id="267" r:id="R06cdcaf8f1504320"/>
+    <p:sldId xmlns:r="http://schemas.openxmlformats.org/officeDocument/2006/relationships" id="268" r:id="Rdc6ab13349e44b14"/>
+    <p:sldId xmlns:r="http://schemas.openxmlformats.org/officeDocument/2006/relationships" id="269" r:id="R61cef4086e1a4c43"/>
+    <p:sldId xmlns:r="http://schemas.openxmlformats.org/officeDocument/2006/relationships" id="270" r:id="R244e9631a10146f7"/>
+    <p:sldId xmlns:r="http://schemas.openxmlformats.org/officeDocument/2006/relationships" id="271" r:id="Racc6f83b4f6c410b"/>
+    <p:sldId xmlns:r="http://schemas.openxmlformats.org/officeDocument/2006/relationships" id="272" r:id="R229eb3109ba34c01"/>
+    <p:sldId xmlns:r="http://schemas.openxmlformats.org/officeDocument/2006/relationships" id="273" r:id="R24b2d98e6c8741ac"/>
   </p:sldIdLst>
   <p:sldSz cx="12192000" cy="6858000"/>
   <p:notesSz cx="6858000" cy="9144000"/>
@@ -1417,6 +1417,15 @@
               <a:t>Prerequisites in the repo README: modern Chromium browser, headphones, working mic, prepared Python environment, workshop credential path, and checkpoint folders.</a:t>
             </a:r>
           </a:p>
+          <a:p xmlns:a="http://schemas.openxmlformats.org/drawingml/2006/main">
+            <a:r>
+              <a:t>
+[Sources]
+- https://github.com/aswincsekar/adk-voice-workshop (repository link and QR target; accessed 2026-08-21)
+- https://api.qrserver.com/v1/create-qr-code/ (QR raster generator; accessed 2026-08-21)
+[/Sources]</a:t>
+            </a:r>
+          </a:p>
         </p:txBody>
       </p:sp>
       <p:sp>
@@ -1892,7 +1901,7 @@
   </p:cSld>
   <p:clrMap bg1="lt1" tx1="dk1" bg2="lt2" tx2="dk2" accent1="accent1" accent2="accent2" accent3="accent3" accent4="accent4" accent5="accent5" accent6="accent6" hlink="hlink" folHlink="folHlink"/>
   <p:sldLayoutIdLst>
-    <p:sldLayoutId xmlns:r="http://schemas.openxmlformats.org/officeDocument/2006/relationships" id="2147483649" r:id="Rbe9578ce34eb4828"/>
+    <p:sldLayoutId xmlns:r="http://schemas.openxmlformats.org/officeDocument/2006/relationships" id="2147483649" r:id="Re9a47de645ab429c"/>
   </p:sldLayoutIdLst>
   <p:txStyles>
     <p:titleStyle>
@@ -2502,6 +2511,7 @@
           <a:lstStyle xmlns:a="http://schemas.openxmlformats.org/drawingml/2006/main"/>
           <a:p xmlns:a="http://schemas.openxmlformats.org/drawingml/2006/main">
             <a:pPr algn="l">
+              <a:buNone/>
               <a:defRPr sz="1200" b="1" i="0">
                 <a:solidFill>
                   <a:srgbClr val="159A64"/>
@@ -2552,6 +2562,7 @@
           <a:lstStyle xmlns:a="http://schemas.openxmlformats.org/drawingml/2006/main"/>
           <a:p xmlns:a="http://schemas.openxmlformats.org/drawingml/2006/main">
             <a:pPr algn="l">
+              <a:buNone/>
               <a:defRPr sz="4350" b="1" i="0">
                 <a:solidFill>
                   <a:srgbClr val="163C2C"/>
@@ -2569,6 +2580,7 @@
           </a:p>
           <a:p xmlns:a="http://schemas.openxmlformats.org/drawingml/2006/main">
             <a:pPr algn="l">
+              <a:buNone/>
               <a:defRPr sz="4350" b="1" i="0">
                 <a:solidFill>
                   <a:srgbClr val="163C2C"/>
@@ -2619,6 +2631,7 @@
           <a:lstStyle xmlns:a="http://schemas.openxmlformats.org/drawingml/2006/main"/>
           <a:p xmlns:a="http://schemas.openxmlformats.org/drawingml/2006/main">
             <a:pPr algn="l">
+              <a:buNone/>
               <a:defRPr sz="1950" b="1" i="0">
                 <a:solidFill>
                   <a:srgbClr val="48B985"/>
@@ -2669,6 +2682,7 @@
           <a:lstStyle xmlns:a="http://schemas.openxmlformats.org/drawingml/2006/main"/>
           <a:p xmlns:a="http://schemas.openxmlformats.org/drawingml/2006/main">
             <a:pPr algn="l">
+              <a:buNone/>
               <a:defRPr sz="1350" b="0" i="0">
                 <a:solidFill>
                   <a:srgbClr val="61786E"/>
@@ -3313,6 +3327,7 @@
           <a:lstStyle xmlns:a="http://schemas.openxmlformats.org/drawingml/2006/main"/>
           <a:p xmlns:a="http://schemas.openxmlformats.org/drawingml/2006/main">
             <a:pPr algn="ctr">
+              <a:buNone/>
               <a:defRPr sz="1800" b="1" i="0">
                 <a:solidFill>
                   <a:srgbClr val="F7FBF8"/>
@@ -3363,6 +3378,7 @@
           <a:lstStyle xmlns:a="http://schemas.openxmlformats.org/drawingml/2006/main"/>
           <a:p xmlns:a="http://schemas.openxmlformats.org/drawingml/2006/main">
             <a:pPr algn="ctr">
+              <a:buNone/>
               <a:defRPr sz="1350" b="0" i="0">
                 <a:solidFill>
                   <a:srgbClr val="61786E"/>
@@ -3475,6 +3491,7 @@
           <a:lstStyle xmlns:a="http://schemas.openxmlformats.org/drawingml/2006/main"/>
           <a:p xmlns:a="http://schemas.openxmlformats.org/drawingml/2006/main">
             <a:pPr algn="l">
+              <a:buNone/>
               <a:defRPr sz="1125" b="1" i="0">
                 <a:solidFill>
                   <a:srgbClr val="48B985"/>
@@ -3525,6 +3542,7 @@
           <a:lstStyle xmlns:a="http://schemas.openxmlformats.org/drawingml/2006/main"/>
           <a:p xmlns:a="http://schemas.openxmlformats.org/drawingml/2006/main">
             <a:pPr algn="l">
+              <a:buNone/>
               <a:defRPr sz="3150" b="1" i="0">
                 <a:solidFill>
                   <a:srgbClr val="163C2C"/>
@@ -3575,6 +3593,7 @@
           <a:lstStyle xmlns:a="http://schemas.openxmlformats.org/drawingml/2006/main"/>
           <a:p xmlns:a="http://schemas.openxmlformats.org/drawingml/2006/main">
             <a:pPr algn="l">
+              <a:buNone/>
               <a:defRPr sz="1500" b="0" i="0">
                 <a:solidFill>
                   <a:srgbClr val="61786E"/>
@@ -3656,6 +3675,7 @@
           <a:lstStyle xmlns:a="http://schemas.openxmlformats.org/drawingml/2006/main"/>
           <a:p xmlns:a="http://schemas.openxmlformats.org/drawingml/2006/main">
             <a:pPr algn="l">
+              <a:buNone/>
               <a:defRPr sz="900" b="1" i="0">
                 <a:solidFill>
                   <a:srgbClr val="7F9389"/>
@@ -3706,6 +3726,7 @@
           <a:lstStyle xmlns:a="http://schemas.openxmlformats.org/drawingml/2006/main"/>
           <a:p xmlns:a="http://schemas.openxmlformats.org/drawingml/2006/main">
             <a:pPr algn="r">
+              <a:buNone/>
               <a:defRPr sz="900" b="1" i="0">
                 <a:solidFill>
                   <a:srgbClr val="7F9389"/>
@@ -3756,6 +3777,7 @@
           <a:lstStyle xmlns:a="http://schemas.openxmlformats.org/drawingml/2006/main"/>
           <a:p xmlns:a="http://schemas.openxmlformats.org/drawingml/2006/main">
             <a:pPr algn="l">
+              <a:buNone/>
               <a:defRPr sz="1350" b="1" i="0">
                 <a:solidFill>
                   <a:srgbClr val="159A64"/>
@@ -3806,6 +3828,7 @@
           <a:lstStyle xmlns:a="http://schemas.openxmlformats.org/drawingml/2006/main"/>
           <a:p xmlns:a="http://schemas.openxmlformats.org/drawingml/2006/main">
             <a:pPr algn="l">
+              <a:buNone/>
               <a:defRPr sz="1800" b="1" i="0">
                 <a:solidFill>
                   <a:srgbClr val="163C2C"/>
@@ -3856,6 +3879,7 @@
           <a:lstStyle xmlns:a="http://schemas.openxmlformats.org/drawingml/2006/main"/>
           <a:p xmlns:a="http://schemas.openxmlformats.org/drawingml/2006/main">
             <a:pPr algn="l">
+              <a:buNone/>
               <a:defRPr sz="1650" b="0" i="0">
                 <a:solidFill>
                   <a:srgbClr val="61786E"/>
@@ -3937,6 +3961,7 @@
           <a:lstStyle xmlns:a="http://schemas.openxmlformats.org/drawingml/2006/main"/>
           <a:p xmlns:a="http://schemas.openxmlformats.org/drawingml/2006/main">
             <a:pPr algn="l">
+              <a:buNone/>
               <a:defRPr sz="1350" b="1" i="0">
                 <a:solidFill>
                   <a:srgbClr val="D05B65"/>
@@ -3987,6 +4012,7 @@
           <a:lstStyle xmlns:a="http://schemas.openxmlformats.org/drawingml/2006/main"/>
           <a:p xmlns:a="http://schemas.openxmlformats.org/drawingml/2006/main">
             <a:pPr algn="l">
+              <a:buNone/>
               <a:defRPr sz="1800" b="1" i="0">
                 <a:solidFill>
                   <a:srgbClr val="163C2C"/>
@@ -4037,6 +4063,7 @@
           <a:lstStyle xmlns:a="http://schemas.openxmlformats.org/drawingml/2006/main"/>
           <a:p xmlns:a="http://schemas.openxmlformats.org/drawingml/2006/main">
             <a:pPr algn="l">
+              <a:buNone/>
               <a:defRPr sz="1650" b="0" i="0">
                 <a:solidFill>
                   <a:srgbClr val="61786E"/>
@@ -4118,6 +4145,7 @@
           <a:lstStyle xmlns:a="http://schemas.openxmlformats.org/drawingml/2006/main"/>
           <a:p xmlns:a="http://schemas.openxmlformats.org/drawingml/2006/main">
             <a:pPr algn="l">
+              <a:buNone/>
               <a:defRPr sz="1350" b="1" i="0">
                 <a:solidFill>
                   <a:srgbClr val="7FA847"/>
@@ -4168,6 +4196,7 @@
           <a:lstStyle xmlns:a="http://schemas.openxmlformats.org/drawingml/2006/main"/>
           <a:p xmlns:a="http://schemas.openxmlformats.org/drawingml/2006/main">
             <a:pPr algn="l">
+              <a:buNone/>
               <a:defRPr sz="1800" b="1" i="0">
                 <a:solidFill>
                   <a:srgbClr val="163C2C"/>
@@ -4218,6 +4247,7 @@
           <a:lstStyle xmlns:a="http://schemas.openxmlformats.org/drawingml/2006/main"/>
           <a:p xmlns:a="http://schemas.openxmlformats.org/drawingml/2006/main">
             <a:pPr algn="l">
+              <a:buNone/>
               <a:defRPr sz="1650" b="0" i="0">
                 <a:solidFill>
                   <a:srgbClr val="61786E"/>
@@ -4299,6 +4329,7 @@
           <a:lstStyle xmlns:a="http://schemas.openxmlformats.org/drawingml/2006/main"/>
           <a:p xmlns:a="http://schemas.openxmlformats.org/drawingml/2006/main">
             <a:pPr algn="l">
+              <a:buNone/>
               <a:defRPr sz="1350" b="1" i="0">
                 <a:solidFill>
                   <a:srgbClr val="48B985"/>
@@ -4349,6 +4380,7 @@
           <a:lstStyle xmlns:a="http://schemas.openxmlformats.org/drawingml/2006/main"/>
           <a:p xmlns:a="http://schemas.openxmlformats.org/drawingml/2006/main">
             <a:pPr algn="l">
+              <a:buNone/>
               <a:defRPr sz="1800" b="1" i="0">
                 <a:solidFill>
                   <a:srgbClr val="163C2C"/>
@@ -4399,6 +4431,7 @@
           <a:lstStyle xmlns:a="http://schemas.openxmlformats.org/drawingml/2006/main"/>
           <a:p xmlns:a="http://schemas.openxmlformats.org/drawingml/2006/main">
             <a:pPr algn="l">
+              <a:buNone/>
               <a:defRPr sz="1650" b="0" i="0">
                 <a:solidFill>
                   <a:srgbClr val="61786E"/>
@@ -4480,6 +4513,7 @@
           <a:lstStyle xmlns:a="http://schemas.openxmlformats.org/drawingml/2006/main"/>
           <a:p xmlns:a="http://schemas.openxmlformats.org/drawingml/2006/main">
             <a:pPr algn="ctr">
+              <a:buNone/>
               <a:defRPr sz="1875" b="1" i="0">
                 <a:solidFill>
                   <a:srgbClr val="48B985"/>
@@ -4592,6 +4626,7 @@
           <a:lstStyle xmlns:a="http://schemas.openxmlformats.org/drawingml/2006/main"/>
           <a:p xmlns:a="http://schemas.openxmlformats.org/drawingml/2006/main">
             <a:pPr algn="l">
+              <a:buNone/>
               <a:defRPr sz="1125" b="1" i="0">
                 <a:solidFill>
                   <a:srgbClr val="159A64"/>
@@ -4642,6 +4677,7 @@
           <a:lstStyle xmlns:a="http://schemas.openxmlformats.org/drawingml/2006/main"/>
           <a:p xmlns:a="http://schemas.openxmlformats.org/drawingml/2006/main">
             <a:pPr algn="l">
+              <a:buNone/>
               <a:defRPr sz="3150" b="1" i="0">
                 <a:solidFill>
                   <a:srgbClr val="163C2C"/>
@@ -4692,6 +4728,7 @@
           <a:lstStyle xmlns:a="http://schemas.openxmlformats.org/drawingml/2006/main"/>
           <a:p xmlns:a="http://schemas.openxmlformats.org/drawingml/2006/main">
             <a:pPr algn="l">
+              <a:buNone/>
               <a:defRPr sz="1500" b="0" i="0">
                 <a:solidFill>
                   <a:srgbClr val="61786E"/>
@@ -4773,6 +4810,7 @@
           <a:lstStyle xmlns:a="http://schemas.openxmlformats.org/drawingml/2006/main"/>
           <a:p xmlns:a="http://schemas.openxmlformats.org/drawingml/2006/main">
             <a:pPr algn="l">
+              <a:buNone/>
               <a:defRPr sz="900" b="1" i="0">
                 <a:solidFill>
                   <a:srgbClr val="7F9389"/>
@@ -4823,6 +4861,7 @@
           <a:lstStyle xmlns:a="http://schemas.openxmlformats.org/drawingml/2006/main"/>
           <a:p xmlns:a="http://schemas.openxmlformats.org/drawingml/2006/main">
             <a:pPr algn="r">
+              <a:buNone/>
               <a:defRPr sz="900" b="1" i="0">
                 <a:solidFill>
                   <a:srgbClr val="7F9389"/>
@@ -4873,6 +4912,7 @@
           <a:lstStyle xmlns:a="http://schemas.openxmlformats.org/drawingml/2006/main"/>
           <a:p xmlns:a="http://schemas.openxmlformats.org/drawingml/2006/main">
             <a:pPr algn="l">
+              <a:buNone/>
               <a:defRPr sz="1350" b="1" i="0">
                 <a:solidFill>
                   <a:srgbClr val="48B985"/>
@@ -5352,6 +5392,7 @@
           <a:lstStyle xmlns:a="http://schemas.openxmlformats.org/drawingml/2006/main"/>
           <a:p xmlns:a="http://schemas.openxmlformats.org/drawingml/2006/main">
             <a:pPr algn="l">
+              <a:buNone/>
               <a:defRPr sz="1350" b="1" i="0">
                 <a:solidFill>
                   <a:srgbClr val="159A64"/>
@@ -6029,6 +6070,7 @@
           <a:lstStyle xmlns:a="http://schemas.openxmlformats.org/drawingml/2006/main"/>
           <a:p xmlns:a="http://schemas.openxmlformats.org/drawingml/2006/main">
             <a:pPr algn="ctr">
+              <a:buNone/>
               <a:defRPr sz="1275" b="1" i="0">
                 <a:solidFill>
                   <a:srgbClr val="D05B65"/>
@@ -6079,6 +6121,7 @@
           <a:lstStyle xmlns:a="http://schemas.openxmlformats.org/drawingml/2006/main"/>
           <a:p xmlns:a="http://schemas.openxmlformats.org/drawingml/2006/main">
             <a:pPr algn="l">
+              <a:buNone/>
               <a:defRPr sz="1500" b="1" i="0">
                 <a:solidFill>
                   <a:srgbClr val="7FA847"/>
@@ -6129,6 +6172,7 @@
           <a:lstStyle xmlns:a="http://schemas.openxmlformats.org/drawingml/2006/main"/>
           <a:p xmlns:a="http://schemas.openxmlformats.org/drawingml/2006/main">
             <a:pPr algn="l">
+              <a:buNone/>
               <a:defRPr sz="1500" b="0" i="0">
                 <a:solidFill>
                   <a:srgbClr val="163C2C"/>
@@ -6179,6 +6223,7 @@
           <a:lstStyle xmlns:a="http://schemas.openxmlformats.org/drawingml/2006/main"/>
           <a:p xmlns:a="http://schemas.openxmlformats.org/drawingml/2006/main">
             <a:pPr algn="l">
+              <a:buNone/>
               <a:defRPr sz="1500" b="1" i="0">
                 <a:solidFill>
                   <a:srgbClr val="D05B65"/>
@@ -6229,6 +6274,7 @@
           <a:lstStyle xmlns:a="http://schemas.openxmlformats.org/drawingml/2006/main"/>
           <a:p xmlns:a="http://schemas.openxmlformats.org/drawingml/2006/main">
             <a:pPr algn="l">
+              <a:buNone/>
               <a:defRPr sz="1500" b="0" i="0">
                 <a:solidFill>
                   <a:srgbClr val="163C2C"/>
@@ -6279,6 +6325,7 @@
           <a:lstStyle xmlns:a="http://schemas.openxmlformats.org/drawingml/2006/main"/>
           <a:p xmlns:a="http://schemas.openxmlformats.org/drawingml/2006/main">
             <a:pPr algn="l">
+              <a:buNone/>
               <a:defRPr sz="1500" b="1" i="0">
                 <a:solidFill>
                   <a:srgbClr val="48B985"/>
@@ -6329,6 +6376,7 @@
           <a:lstStyle xmlns:a="http://schemas.openxmlformats.org/drawingml/2006/main"/>
           <a:p xmlns:a="http://schemas.openxmlformats.org/drawingml/2006/main">
             <a:pPr algn="l">
+              <a:buNone/>
               <a:defRPr sz="1500" b="0" i="0">
                 <a:solidFill>
                   <a:srgbClr val="163C2C"/>
@@ -6379,6 +6427,7 @@
           <a:lstStyle xmlns:a="http://schemas.openxmlformats.org/drawingml/2006/main"/>
           <a:p xmlns:a="http://schemas.openxmlformats.org/drawingml/2006/main">
             <a:pPr algn="ctr">
+              <a:buNone/>
               <a:defRPr sz="1725" b="1" i="0">
                 <a:solidFill>
                   <a:srgbClr val="48B985"/>
@@ -6491,6 +6540,7 @@
           <a:lstStyle xmlns:a="http://schemas.openxmlformats.org/drawingml/2006/main"/>
           <a:p xmlns:a="http://schemas.openxmlformats.org/drawingml/2006/main">
             <a:pPr algn="l">
+              <a:buNone/>
               <a:defRPr sz="1125" b="1" i="0">
                 <a:solidFill>
                   <a:srgbClr val="159A64"/>
@@ -6541,6 +6591,7 @@
           <a:lstStyle xmlns:a="http://schemas.openxmlformats.org/drawingml/2006/main"/>
           <a:p xmlns:a="http://schemas.openxmlformats.org/drawingml/2006/main">
             <a:pPr algn="l">
+              <a:buNone/>
               <a:defRPr sz="3150" b="1" i="0">
                 <a:solidFill>
                   <a:srgbClr val="163C2C"/>
@@ -6591,6 +6642,7 @@
           <a:lstStyle xmlns:a="http://schemas.openxmlformats.org/drawingml/2006/main"/>
           <a:p xmlns:a="http://schemas.openxmlformats.org/drawingml/2006/main">
             <a:pPr algn="l">
+              <a:buNone/>
               <a:defRPr sz="1500" b="0" i="0">
                 <a:solidFill>
                   <a:srgbClr val="61786E"/>
@@ -6672,6 +6724,7 @@
           <a:lstStyle xmlns:a="http://schemas.openxmlformats.org/drawingml/2006/main"/>
           <a:p xmlns:a="http://schemas.openxmlformats.org/drawingml/2006/main">
             <a:pPr algn="l">
+              <a:buNone/>
               <a:defRPr sz="900" b="1" i="0">
                 <a:solidFill>
                   <a:srgbClr val="7F9389"/>
@@ -6722,6 +6775,7 @@
           <a:lstStyle xmlns:a="http://schemas.openxmlformats.org/drawingml/2006/main"/>
           <a:p xmlns:a="http://schemas.openxmlformats.org/drawingml/2006/main">
             <a:pPr algn="r">
+              <a:buNone/>
               <a:defRPr sz="900" b="1" i="0">
                 <a:solidFill>
                   <a:srgbClr val="7F9389"/>
@@ -6805,6 +6859,7 @@
           <a:lstStyle xmlns:a="http://schemas.openxmlformats.org/drawingml/2006/main"/>
           <a:p xmlns:a="http://schemas.openxmlformats.org/drawingml/2006/main">
             <a:pPr algn="ctr">
+              <a:buNone/>
               <a:defRPr sz="1350" b="1" i="0">
                 <a:solidFill>
                   <a:srgbClr val="48B985"/>
@@ -6888,6 +6943,7 @@
           <a:lstStyle xmlns:a="http://schemas.openxmlformats.org/drawingml/2006/main"/>
           <a:p xmlns:a="http://schemas.openxmlformats.org/drawingml/2006/main">
             <a:pPr algn="ctr">
+              <a:buNone/>
               <a:defRPr sz="1350" b="1" i="0">
                 <a:solidFill>
                   <a:srgbClr val="159A64"/>
@@ -6973,6 +7029,7 @@
           <a:lstStyle xmlns:a="http://schemas.openxmlformats.org/drawingml/2006/main"/>
           <a:p xmlns:a="http://schemas.openxmlformats.org/drawingml/2006/main">
             <a:pPr algn="ctr">
+              <a:buNone/>
               <a:defRPr sz="1575" b="1" i="0">
                 <a:solidFill>
                   <a:srgbClr val="163C2C"/>
@@ -7023,6 +7080,7 @@
           <a:lstStyle xmlns:a="http://schemas.openxmlformats.org/drawingml/2006/main"/>
           <a:p xmlns:a="http://schemas.openxmlformats.org/drawingml/2006/main">
             <a:pPr algn="ctr">
+              <a:buNone/>
               <a:defRPr sz="1350" b="0" i="0">
                 <a:solidFill>
                   <a:srgbClr val="61786E"/>
@@ -7108,6 +7166,7 @@
           <a:lstStyle xmlns:a="http://schemas.openxmlformats.org/drawingml/2006/main"/>
           <a:p xmlns:a="http://schemas.openxmlformats.org/drawingml/2006/main">
             <a:pPr algn="ctr">
+              <a:buNone/>
               <a:defRPr sz="1575" b="1" i="0">
                 <a:solidFill>
                   <a:srgbClr val="163C2C"/>
@@ -7158,6 +7217,7 @@
           <a:lstStyle xmlns:a="http://schemas.openxmlformats.org/drawingml/2006/main"/>
           <a:p xmlns:a="http://schemas.openxmlformats.org/drawingml/2006/main">
             <a:pPr algn="ctr">
+              <a:buNone/>
               <a:defRPr sz="1350" b="0" i="0">
                 <a:solidFill>
                   <a:srgbClr val="61786E"/>
@@ -7243,6 +7303,7 @@
           <a:lstStyle xmlns:a="http://schemas.openxmlformats.org/drawingml/2006/main"/>
           <a:p xmlns:a="http://schemas.openxmlformats.org/drawingml/2006/main">
             <a:pPr algn="ctr">
+              <a:buNone/>
               <a:defRPr sz="1575" b="1" i="0">
                 <a:solidFill>
                   <a:srgbClr val="48B985"/>
@@ -7293,6 +7354,7 @@
           <a:lstStyle xmlns:a="http://schemas.openxmlformats.org/drawingml/2006/main"/>
           <a:p xmlns:a="http://schemas.openxmlformats.org/drawingml/2006/main">
             <a:pPr algn="ctr">
+              <a:buNone/>
               <a:defRPr sz="1350" b="0" i="0">
                 <a:solidFill>
                   <a:srgbClr val="61786E"/>
@@ -7378,6 +7440,7 @@
           <a:lstStyle xmlns:a="http://schemas.openxmlformats.org/drawingml/2006/main"/>
           <a:p xmlns:a="http://schemas.openxmlformats.org/drawingml/2006/main">
             <a:pPr algn="ctr">
+              <a:buNone/>
               <a:defRPr sz="1575" b="1" i="0">
                 <a:solidFill>
                   <a:srgbClr val="159A64"/>
@@ -7428,6 +7491,7 @@
           <a:lstStyle xmlns:a="http://schemas.openxmlformats.org/drawingml/2006/main"/>
           <a:p xmlns:a="http://schemas.openxmlformats.org/drawingml/2006/main">
             <a:pPr algn="ctr">
+              <a:buNone/>
               <a:defRPr sz="1350" b="0" i="0">
                 <a:solidFill>
                   <a:srgbClr val="61786E"/>
@@ -7478,6 +7542,7 @@
           <a:lstStyle xmlns:a="http://schemas.openxmlformats.org/drawingml/2006/main"/>
           <a:p xmlns:a="http://schemas.openxmlformats.org/drawingml/2006/main">
             <a:pPr algn="ctr">
+              <a:buNone/>
               <a:defRPr sz="1350" b="1" i="0">
                 <a:solidFill>
                   <a:srgbClr val="48B985"/>
@@ -7528,6 +7593,7 @@
           <a:lstStyle xmlns:a="http://schemas.openxmlformats.org/drawingml/2006/main"/>
           <a:p xmlns:a="http://schemas.openxmlformats.org/drawingml/2006/main">
             <a:pPr algn="ctr">
+              <a:buNone/>
               <a:defRPr sz="1650" b="1" i="0">
                 <a:solidFill>
                   <a:srgbClr val="61786E"/>
@@ -7578,6 +7644,7 @@
           <a:lstStyle xmlns:a="http://schemas.openxmlformats.org/drawingml/2006/main"/>
           <a:p xmlns:a="http://schemas.openxmlformats.org/drawingml/2006/main">
             <a:pPr algn="ctr">
+              <a:buNone/>
               <a:defRPr sz="1350" b="1" i="0">
                 <a:solidFill>
                   <a:srgbClr val="159A64"/>
@@ -7690,6 +7757,7 @@
           <a:lstStyle xmlns:a="http://schemas.openxmlformats.org/drawingml/2006/main"/>
           <a:p xmlns:a="http://schemas.openxmlformats.org/drawingml/2006/main">
             <a:pPr algn="l">
+              <a:buNone/>
               <a:defRPr sz="1125" b="1" i="0">
                 <a:solidFill>
                   <a:srgbClr val="159A64"/>
@@ -7740,6 +7808,7 @@
           <a:lstStyle xmlns:a="http://schemas.openxmlformats.org/drawingml/2006/main"/>
           <a:p xmlns:a="http://schemas.openxmlformats.org/drawingml/2006/main">
             <a:pPr algn="l">
+              <a:buNone/>
               <a:defRPr sz="3150" b="1" i="0">
                 <a:solidFill>
                   <a:srgbClr val="163C2C"/>
@@ -7790,6 +7859,7 @@
           <a:lstStyle xmlns:a="http://schemas.openxmlformats.org/drawingml/2006/main"/>
           <a:p xmlns:a="http://schemas.openxmlformats.org/drawingml/2006/main">
             <a:pPr algn="l">
+              <a:buNone/>
               <a:defRPr sz="1500" b="0" i="0">
                 <a:solidFill>
                   <a:srgbClr val="61786E"/>
@@ -7871,6 +7941,7 @@
           <a:lstStyle xmlns:a="http://schemas.openxmlformats.org/drawingml/2006/main"/>
           <a:p xmlns:a="http://schemas.openxmlformats.org/drawingml/2006/main">
             <a:pPr algn="l">
+              <a:buNone/>
               <a:defRPr sz="900" b="1" i="0">
                 <a:solidFill>
                   <a:srgbClr val="7F9389"/>
@@ -7921,6 +7992,7 @@
           <a:lstStyle xmlns:a="http://schemas.openxmlformats.org/drawingml/2006/main"/>
           <a:p xmlns:a="http://schemas.openxmlformats.org/drawingml/2006/main">
             <a:pPr algn="r">
+              <a:buNone/>
               <a:defRPr sz="900" b="1" i="0">
                 <a:solidFill>
                   <a:srgbClr val="7F9389"/>
@@ -8132,6 +8204,7 @@
           <a:lstStyle xmlns:a="http://schemas.openxmlformats.org/drawingml/2006/main"/>
           <a:p xmlns:a="http://schemas.openxmlformats.org/drawingml/2006/main">
             <a:pPr algn="l">
+              <a:buNone/>
               <a:defRPr sz="1200" b="0" i="0">
                 <a:solidFill>
                   <a:srgbClr val="F7FBF8"/>
@@ -8149,6 +8222,7 @@
           </a:p>
           <a:p xmlns:a="http://schemas.openxmlformats.org/drawingml/2006/main">
             <a:pPr algn="l">
+              <a:buNone/>
               <a:defRPr sz="1200" b="0" i="0">
                 <a:solidFill>
                   <a:srgbClr val="F7FBF8"/>
@@ -8166,6 +8240,7 @@
           </a:p>
           <a:p xmlns:a="http://schemas.openxmlformats.org/drawingml/2006/main">
             <a:pPr algn="l">
+              <a:buNone/>
               <a:defRPr sz="1200" b="0" i="0">
                 <a:solidFill>
                   <a:srgbClr val="F7FBF8"/>
@@ -8183,6 +8258,7 @@
           </a:p>
           <a:p xmlns:a="http://schemas.openxmlformats.org/drawingml/2006/main">
             <a:pPr algn="l">
+              <a:buNone/>
               <a:defRPr sz="1200" b="0" i="0">
                 <a:solidFill>
                   <a:srgbClr val="F7FBF8"/>
@@ -8200,6 +8276,7 @@
           </a:p>
           <a:p xmlns:a="http://schemas.openxmlformats.org/drawingml/2006/main">
             <a:pPr algn="l">
+              <a:buNone/>
               <a:defRPr sz="1200" b="0" i="0">
                 <a:solidFill>
                   <a:srgbClr val="F7FBF8"/>
@@ -8217,6 +8294,7 @@
           </a:p>
           <a:p xmlns:a="http://schemas.openxmlformats.org/drawingml/2006/main">
             <a:pPr algn="l">
+              <a:buNone/>
               <a:defRPr sz="1200" b="0" i="0">
                 <a:solidFill>
                   <a:srgbClr val="F7FBF8"/>
@@ -8234,6 +8312,7 @@
           </a:p>
           <a:p xmlns:a="http://schemas.openxmlformats.org/drawingml/2006/main">
             <a:pPr algn="l">
+              <a:buNone/>
               <a:defRPr sz="1200" b="0" i="0">
                 <a:solidFill>
                   <a:srgbClr val="F7FBF8"/>
@@ -8284,6 +8363,7 @@
           <a:lstStyle xmlns:a="http://schemas.openxmlformats.org/drawingml/2006/main"/>
           <a:p xmlns:a="http://schemas.openxmlformats.org/drawingml/2006/main">
             <a:pPr algn="l">
+              <a:buNone/>
               <a:defRPr sz="1275" b="1" i="0">
                 <a:solidFill>
                   <a:srgbClr val="159A64"/>
@@ -8334,6 +8414,7 @@
           <a:lstStyle xmlns:a="http://schemas.openxmlformats.org/drawingml/2006/main"/>
           <a:p xmlns:a="http://schemas.openxmlformats.org/drawingml/2006/main">
             <a:pPr algn="l">
+              <a:buNone/>
               <a:defRPr sz="1500" b="0" i="0">
                 <a:solidFill>
                   <a:srgbClr val="163C2C"/>
@@ -8415,6 +8496,7 @@
           <a:lstStyle xmlns:a="http://schemas.openxmlformats.org/drawingml/2006/main"/>
           <a:p xmlns:a="http://schemas.openxmlformats.org/drawingml/2006/main">
             <a:pPr algn="l">
+              <a:buNone/>
               <a:defRPr sz="1275" b="1" i="0">
                 <a:solidFill>
                   <a:srgbClr val="48B985"/>
@@ -8465,6 +8547,7 @@
           <a:lstStyle xmlns:a="http://schemas.openxmlformats.org/drawingml/2006/main"/>
           <a:p xmlns:a="http://schemas.openxmlformats.org/drawingml/2006/main">
             <a:pPr algn="l">
+              <a:buNone/>
               <a:defRPr sz="1500" b="0" i="0">
                 <a:solidFill>
                   <a:srgbClr val="163C2C"/>
@@ -8546,6 +8629,7 @@
           <a:lstStyle xmlns:a="http://schemas.openxmlformats.org/drawingml/2006/main"/>
           <a:p xmlns:a="http://schemas.openxmlformats.org/drawingml/2006/main">
             <a:pPr algn="l">
+              <a:buNone/>
               <a:defRPr sz="1275" b="1" i="0">
                 <a:solidFill>
                   <a:srgbClr val="7FA847"/>
@@ -8596,6 +8680,7 @@
           <a:lstStyle xmlns:a="http://schemas.openxmlformats.org/drawingml/2006/main"/>
           <a:p xmlns:a="http://schemas.openxmlformats.org/drawingml/2006/main">
             <a:pPr algn="l">
+              <a:buNone/>
               <a:defRPr sz="1500" b="0" i="0">
                 <a:solidFill>
                   <a:srgbClr val="163C2C"/>
@@ -8677,6 +8762,7 @@
           <a:lstStyle xmlns:a="http://schemas.openxmlformats.org/drawingml/2006/main"/>
           <a:p xmlns:a="http://schemas.openxmlformats.org/drawingml/2006/main">
             <a:pPr algn="l">
+              <a:buNone/>
               <a:defRPr sz="1275" b="1" i="0">
                 <a:solidFill>
                   <a:srgbClr val="D05B65"/>
@@ -8727,6 +8813,7 @@
           <a:lstStyle xmlns:a="http://schemas.openxmlformats.org/drawingml/2006/main"/>
           <a:p xmlns:a="http://schemas.openxmlformats.org/drawingml/2006/main">
             <a:pPr algn="l">
+              <a:buNone/>
               <a:defRPr sz="1500" b="0" i="0">
                 <a:solidFill>
                   <a:srgbClr val="163C2C"/>
@@ -8808,6 +8895,7 @@
           <a:lstStyle xmlns:a="http://schemas.openxmlformats.org/drawingml/2006/main"/>
           <a:p xmlns:a="http://schemas.openxmlformats.org/drawingml/2006/main">
             <a:pPr algn="l">
+              <a:buNone/>
               <a:defRPr sz="1575" b="1" i="0">
                 <a:solidFill>
                   <a:srgbClr val="48B985"/>
@@ -8920,6 +9008,7 @@
           <a:lstStyle xmlns:a="http://schemas.openxmlformats.org/drawingml/2006/main"/>
           <a:p xmlns:a="http://schemas.openxmlformats.org/drawingml/2006/main">
             <a:pPr algn="l">
+              <a:buNone/>
               <a:defRPr sz="1125" b="1" i="0">
                 <a:solidFill>
                   <a:srgbClr val="159A64"/>
@@ -8970,6 +9059,7 @@
           <a:lstStyle xmlns:a="http://schemas.openxmlformats.org/drawingml/2006/main"/>
           <a:p xmlns:a="http://schemas.openxmlformats.org/drawingml/2006/main">
             <a:pPr algn="l">
+              <a:buNone/>
               <a:defRPr sz="3150" b="1" i="0">
                 <a:solidFill>
                   <a:srgbClr val="163C2C"/>
@@ -9020,6 +9110,7 @@
           <a:lstStyle xmlns:a="http://schemas.openxmlformats.org/drawingml/2006/main"/>
           <a:p xmlns:a="http://schemas.openxmlformats.org/drawingml/2006/main">
             <a:pPr algn="l">
+              <a:buNone/>
               <a:defRPr sz="1500" b="0" i="0">
                 <a:solidFill>
                   <a:srgbClr val="61786E"/>
@@ -9101,6 +9192,7 @@
           <a:lstStyle xmlns:a="http://schemas.openxmlformats.org/drawingml/2006/main"/>
           <a:p xmlns:a="http://schemas.openxmlformats.org/drawingml/2006/main">
             <a:pPr algn="l">
+              <a:buNone/>
               <a:defRPr sz="900" b="1" i="0">
                 <a:solidFill>
                   <a:srgbClr val="7F9389"/>
@@ -9151,6 +9243,7 @@
           <a:lstStyle xmlns:a="http://schemas.openxmlformats.org/drawingml/2006/main"/>
           <a:p xmlns:a="http://schemas.openxmlformats.org/drawingml/2006/main">
             <a:pPr algn="r">
+              <a:buNone/>
               <a:defRPr sz="900" b="1" i="0">
                 <a:solidFill>
                   <a:srgbClr val="7F9389"/>
@@ -9263,6 +9356,7 @@
           <a:lstStyle xmlns:a="http://schemas.openxmlformats.org/drawingml/2006/main"/>
           <a:p xmlns:a="http://schemas.openxmlformats.org/drawingml/2006/main">
             <a:pPr algn="ctr">
+              <a:buNone/>
               <a:defRPr sz="1350" b="1" i="0">
                 <a:solidFill>
                   <a:srgbClr val="159A64"/>
@@ -9313,6 +9407,7 @@
           <a:lstStyle xmlns:a="http://schemas.openxmlformats.org/drawingml/2006/main"/>
           <a:p xmlns:a="http://schemas.openxmlformats.org/drawingml/2006/main">
             <a:pPr algn="ctr">
+              <a:buNone/>
               <a:defRPr sz="1200" b="1" i="0">
                 <a:solidFill>
                   <a:srgbClr val="163C2C"/>
@@ -9394,6 +9489,7 @@
           <a:lstStyle xmlns:a="http://schemas.openxmlformats.org/drawingml/2006/main"/>
           <a:p xmlns:a="http://schemas.openxmlformats.org/drawingml/2006/main">
             <a:pPr algn="ctr">
+              <a:buNone/>
               <a:defRPr sz="1350" b="1" i="0">
                 <a:solidFill>
                   <a:srgbClr val="7FA847"/>
@@ -9444,6 +9540,7 @@
           <a:lstStyle xmlns:a="http://schemas.openxmlformats.org/drawingml/2006/main"/>
           <a:p xmlns:a="http://schemas.openxmlformats.org/drawingml/2006/main">
             <a:pPr algn="ctr">
+              <a:buNone/>
               <a:defRPr sz="1200" b="1" i="0">
                 <a:solidFill>
                   <a:srgbClr val="163C2C"/>
@@ -9525,6 +9622,7 @@
           <a:lstStyle xmlns:a="http://schemas.openxmlformats.org/drawingml/2006/main"/>
           <a:p xmlns:a="http://schemas.openxmlformats.org/drawingml/2006/main">
             <a:pPr algn="ctr">
+              <a:buNone/>
               <a:defRPr sz="1350" b="1" i="0">
                 <a:solidFill>
                   <a:srgbClr val="48B985"/>
@@ -9575,6 +9673,7 @@
           <a:lstStyle xmlns:a="http://schemas.openxmlformats.org/drawingml/2006/main"/>
           <a:p xmlns:a="http://schemas.openxmlformats.org/drawingml/2006/main">
             <a:pPr algn="ctr">
+              <a:buNone/>
               <a:defRPr sz="1200" b="1" i="0">
                 <a:solidFill>
                   <a:srgbClr val="163C2C"/>
@@ -9656,6 +9755,7 @@
           <a:lstStyle xmlns:a="http://schemas.openxmlformats.org/drawingml/2006/main"/>
           <a:p xmlns:a="http://schemas.openxmlformats.org/drawingml/2006/main">
             <a:pPr algn="ctr">
+              <a:buNone/>
               <a:defRPr sz="1350" b="1" i="0">
                 <a:solidFill>
                   <a:srgbClr val="159A64"/>
@@ -9706,6 +9806,7 @@
           <a:lstStyle xmlns:a="http://schemas.openxmlformats.org/drawingml/2006/main"/>
           <a:p xmlns:a="http://schemas.openxmlformats.org/drawingml/2006/main">
             <a:pPr algn="ctr">
+              <a:buNone/>
               <a:defRPr sz="1200" b="1" i="0">
                 <a:solidFill>
                   <a:srgbClr val="163C2C"/>
@@ -9789,6 +9890,7 @@
           <a:lstStyle xmlns:a="http://schemas.openxmlformats.org/drawingml/2006/main"/>
           <a:p xmlns:a="http://schemas.openxmlformats.org/drawingml/2006/main">
             <a:pPr algn="ctr">
+              <a:buNone/>
               <a:defRPr sz="1650" b="1" i="0">
                 <a:solidFill>
                   <a:srgbClr val="F7FBF8"/>
@@ -9874,6 +9976,7 @@
           <a:lstStyle xmlns:a="http://schemas.openxmlformats.org/drawingml/2006/main"/>
           <a:p xmlns:a="http://schemas.openxmlformats.org/drawingml/2006/main">
             <a:pPr algn="ctr">
+              <a:buNone/>
               <a:defRPr sz="1425" b="1" i="0">
                 <a:solidFill>
                   <a:srgbClr val="48B985"/>
@@ -9924,6 +10027,7 @@
           <a:lstStyle xmlns:a="http://schemas.openxmlformats.org/drawingml/2006/main"/>
           <a:p xmlns:a="http://schemas.openxmlformats.org/drawingml/2006/main">
             <a:pPr algn="ctr">
+              <a:buNone/>
               <a:defRPr sz="1275" b="0" i="0">
                 <a:solidFill>
                   <a:srgbClr val="163C2C"/>
@@ -9974,6 +10078,7 @@
           <a:lstStyle xmlns:a="http://schemas.openxmlformats.org/drawingml/2006/main"/>
           <a:p xmlns:a="http://schemas.openxmlformats.org/drawingml/2006/main">
             <a:pPr algn="ctr">
+              <a:buNone/>
               <a:defRPr sz="1425" b="1" i="0">
                 <a:solidFill>
                   <a:srgbClr val="61786E"/>
@@ -10086,6 +10191,7 @@
           <a:lstStyle xmlns:a="http://schemas.openxmlformats.org/drawingml/2006/main"/>
           <a:p xmlns:a="http://schemas.openxmlformats.org/drawingml/2006/main">
             <a:pPr algn="l">
+              <a:buNone/>
               <a:defRPr sz="1125" b="1" i="0">
                 <a:solidFill>
                   <a:srgbClr val="7FA847"/>
@@ -10136,6 +10242,7 @@
           <a:lstStyle xmlns:a="http://schemas.openxmlformats.org/drawingml/2006/main"/>
           <a:p xmlns:a="http://schemas.openxmlformats.org/drawingml/2006/main">
             <a:pPr algn="l">
+              <a:buNone/>
               <a:defRPr sz="3150" b="1" i="0">
                 <a:solidFill>
                   <a:srgbClr val="163C2C"/>
@@ -10186,6 +10293,7 @@
           <a:lstStyle xmlns:a="http://schemas.openxmlformats.org/drawingml/2006/main"/>
           <a:p xmlns:a="http://schemas.openxmlformats.org/drawingml/2006/main">
             <a:pPr algn="l">
+              <a:buNone/>
               <a:defRPr sz="1500" b="0" i="0">
                 <a:solidFill>
                   <a:srgbClr val="61786E"/>
@@ -10267,6 +10375,7 @@
           <a:lstStyle xmlns:a="http://schemas.openxmlformats.org/drawingml/2006/main"/>
           <a:p xmlns:a="http://schemas.openxmlformats.org/drawingml/2006/main">
             <a:pPr algn="l">
+              <a:buNone/>
               <a:defRPr sz="900" b="1" i="0">
                 <a:solidFill>
                   <a:srgbClr val="7F9389"/>
@@ -10317,6 +10426,7 @@
           <a:lstStyle xmlns:a="http://schemas.openxmlformats.org/drawingml/2006/main"/>
           <a:p xmlns:a="http://schemas.openxmlformats.org/drawingml/2006/main">
             <a:pPr algn="r">
+              <a:buNone/>
               <a:defRPr sz="900" b="1" i="0">
                 <a:solidFill>
                   <a:srgbClr val="7F9389"/>
@@ -10367,6 +10477,7 @@
           <a:lstStyle xmlns:a="http://schemas.openxmlformats.org/drawingml/2006/main"/>
           <a:p xmlns:a="http://schemas.openxmlformats.org/drawingml/2006/main">
             <a:pPr algn="l">
+              <a:buNone/>
               <a:defRPr sz="1275" b="1" i="0">
                 <a:solidFill>
                   <a:srgbClr val="159A64"/>
@@ -10417,6 +10528,7 @@
           <a:lstStyle xmlns:a="http://schemas.openxmlformats.org/drawingml/2006/main"/>
           <a:p xmlns:a="http://schemas.openxmlformats.org/drawingml/2006/main">
             <a:pPr algn="l">
+              <a:buNone/>
               <a:defRPr sz="1725" b="1" i="0">
                 <a:solidFill>
                   <a:srgbClr val="163C2C"/>
@@ -10498,6 +10610,7 @@
           <a:lstStyle xmlns:a="http://schemas.openxmlformats.org/drawingml/2006/main"/>
           <a:p xmlns:a="http://schemas.openxmlformats.org/drawingml/2006/main">
             <a:pPr algn="l">
+              <a:buNone/>
               <a:defRPr sz="1500" b="0" i="0">
                 <a:solidFill>
                   <a:srgbClr val="61786E"/>
@@ -10548,6 +10661,7 @@
           <a:lstStyle xmlns:a="http://schemas.openxmlformats.org/drawingml/2006/main"/>
           <a:p xmlns:a="http://schemas.openxmlformats.org/drawingml/2006/main">
             <a:pPr algn="l">
+              <a:buNone/>
               <a:defRPr sz="1275" b="1" i="0">
                 <a:solidFill>
                   <a:srgbClr val="7FA847"/>
@@ -10598,6 +10712,7 @@
           <a:lstStyle xmlns:a="http://schemas.openxmlformats.org/drawingml/2006/main"/>
           <a:p xmlns:a="http://schemas.openxmlformats.org/drawingml/2006/main">
             <a:pPr algn="l">
+              <a:buNone/>
               <a:defRPr sz="1725" b="1" i="0">
                 <a:solidFill>
                   <a:srgbClr val="163C2C"/>
@@ -10679,6 +10794,7 @@
           <a:lstStyle xmlns:a="http://schemas.openxmlformats.org/drawingml/2006/main"/>
           <a:p xmlns:a="http://schemas.openxmlformats.org/drawingml/2006/main">
             <a:pPr algn="l">
+              <a:buNone/>
               <a:defRPr sz="1500" b="0" i="0">
                 <a:solidFill>
                   <a:srgbClr val="61786E"/>
@@ -10729,6 +10845,7 @@
           <a:lstStyle xmlns:a="http://schemas.openxmlformats.org/drawingml/2006/main"/>
           <a:p xmlns:a="http://schemas.openxmlformats.org/drawingml/2006/main">
             <a:pPr algn="l">
+              <a:buNone/>
               <a:defRPr sz="1275" b="1" i="0">
                 <a:solidFill>
                   <a:srgbClr val="48B985"/>
@@ -10779,6 +10896,7 @@
           <a:lstStyle xmlns:a="http://schemas.openxmlformats.org/drawingml/2006/main"/>
           <a:p xmlns:a="http://schemas.openxmlformats.org/drawingml/2006/main">
             <a:pPr algn="l">
+              <a:buNone/>
               <a:defRPr sz="1725" b="1" i="0">
                 <a:solidFill>
                   <a:srgbClr val="163C2C"/>
@@ -10860,6 +10978,7 @@
           <a:lstStyle xmlns:a="http://schemas.openxmlformats.org/drawingml/2006/main"/>
           <a:p xmlns:a="http://schemas.openxmlformats.org/drawingml/2006/main">
             <a:pPr algn="l">
+              <a:buNone/>
               <a:defRPr sz="1500" b="0" i="0">
                 <a:solidFill>
                   <a:srgbClr val="61786E"/>
@@ -10910,6 +11029,7 @@
           <a:lstStyle xmlns:a="http://schemas.openxmlformats.org/drawingml/2006/main"/>
           <a:p xmlns:a="http://schemas.openxmlformats.org/drawingml/2006/main">
             <a:pPr algn="l">
+              <a:buNone/>
               <a:defRPr sz="1275" b="1" i="0">
                 <a:solidFill>
                   <a:srgbClr val="6FAF8D"/>
@@ -10960,6 +11080,7 @@
           <a:lstStyle xmlns:a="http://schemas.openxmlformats.org/drawingml/2006/main"/>
           <a:p xmlns:a="http://schemas.openxmlformats.org/drawingml/2006/main">
             <a:pPr algn="l">
+              <a:buNone/>
               <a:defRPr sz="1725" b="1" i="0">
                 <a:solidFill>
                   <a:srgbClr val="163C2C"/>
@@ -11041,6 +11162,7 @@
           <a:lstStyle xmlns:a="http://schemas.openxmlformats.org/drawingml/2006/main"/>
           <a:p xmlns:a="http://schemas.openxmlformats.org/drawingml/2006/main">
             <a:pPr algn="l">
+              <a:buNone/>
               <a:defRPr sz="1500" b="0" i="0">
                 <a:solidFill>
                   <a:srgbClr val="61786E"/>
@@ -11126,6 +11248,7 @@
           <a:lstStyle xmlns:a="http://schemas.openxmlformats.org/drawingml/2006/main"/>
           <a:p xmlns:a="http://schemas.openxmlformats.org/drawingml/2006/main">
             <a:pPr algn="ctr">
+              <a:buNone/>
               <a:defRPr sz="1575" b="1" i="0">
                 <a:solidFill>
                   <a:srgbClr val="48B985"/>
@@ -11238,6 +11361,7 @@
           <a:lstStyle xmlns:a="http://schemas.openxmlformats.org/drawingml/2006/main"/>
           <a:p xmlns:a="http://schemas.openxmlformats.org/drawingml/2006/main">
             <a:pPr algn="l">
+              <a:buNone/>
               <a:defRPr sz="1125" b="1" i="0">
                 <a:solidFill>
                   <a:srgbClr val="159A64"/>
@@ -11288,6 +11412,7 @@
           <a:lstStyle xmlns:a="http://schemas.openxmlformats.org/drawingml/2006/main"/>
           <a:p xmlns:a="http://schemas.openxmlformats.org/drawingml/2006/main">
             <a:pPr algn="l">
+              <a:buNone/>
               <a:defRPr sz="3150" b="1" i="0">
                 <a:solidFill>
                   <a:srgbClr val="163C2C"/>
@@ -11338,6 +11463,7 @@
           <a:lstStyle xmlns:a="http://schemas.openxmlformats.org/drawingml/2006/main"/>
           <a:p xmlns:a="http://schemas.openxmlformats.org/drawingml/2006/main">
             <a:pPr algn="l">
+              <a:buNone/>
               <a:defRPr sz="1500" b="0" i="0">
                 <a:solidFill>
                   <a:srgbClr val="61786E"/>
@@ -11419,6 +11545,7 @@
           <a:lstStyle xmlns:a="http://schemas.openxmlformats.org/drawingml/2006/main"/>
           <a:p xmlns:a="http://schemas.openxmlformats.org/drawingml/2006/main">
             <a:pPr algn="l">
+              <a:buNone/>
               <a:defRPr sz="900" b="1" i="0">
                 <a:solidFill>
                   <a:srgbClr val="7F9389"/>
@@ -11469,6 +11596,7 @@
           <a:lstStyle xmlns:a="http://schemas.openxmlformats.org/drawingml/2006/main"/>
           <a:p xmlns:a="http://schemas.openxmlformats.org/drawingml/2006/main">
             <a:pPr algn="r">
+              <a:buNone/>
               <a:defRPr sz="900" b="1" i="0">
                 <a:solidFill>
                   <a:srgbClr val="7F9389"/>
@@ -11519,6 +11647,7 @@
           <a:lstStyle xmlns:a="http://schemas.openxmlformats.org/drawingml/2006/main"/>
           <a:p xmlns:a="http://schemas.openxmlformats.org/drawingml/2006/main">
             <a:pPr algn="l">
+              <a:buNone/>
               <a:defRPr sz="1275" b="1" i="0">
                 <a:solidFill>
                   <a:srgbClr val="159A64"/>
@@ -11600,6 +11729,7 @@
           <a:lstStyle xmlns:a="http://schemas.openxmlformats.org/drawingml/2006/main"/>
           <a:p xmlns:a="http://schemas.openxmlformats.org/drawingml/2006/main">
             <a:pPr algn="l">
+              <a:buNone/>
               <a:defRPr sz="1650" b="0" i="0">
                 <a:solidFill>
                   <a:srgbClr val="163C2C"/>
@@ -11650,6 +11780,7 @@
           <a:lstStyle xmlns:a="http://schemas.openxmlformats.org/drawingml/2006/main"/>
           <a:p xmlns:a="http://schemas.openxmlformats.org/drawingml/2006/main">
             <a:pPr algn="l">
+              <a:buNone/>
               <a:defRPr sz="1275" b="1" i="0">
                 <a:solidFill>
                   <a:srgbClr val="6FAF8D"/>
@@ -11731,6 +11862,7 @@
           <a:lstStyle xmlns:a="http://schemas.openxmlformats.org/drawingml/2006/main"/>
           <a:p xmlns:a="http://schemas.openxmlformats.org/drawingml/2006/main">
             <a:pPr algn="l">
+              <a:buNone/>
               <a:defRPr sz="1650" b="0" i="0">
                 <a:solidFill>
                   <a:srgbClr val="163C2C"/>
@@ -11781,6 +11913,7 @@
           <a:lstStyle xmlns:a="http://schemas.openxmlformats.org/drawingml/2006/main"/>
           <a:p xmlns:a="http://schemas.openxmlformats.org/drawingml/2006/main">
             <a:pPr algn="l">
+              <a:buNone/>
               <a:defRPr sz="1275" b="1" i="0">
                 <a:solidFill>
                   <a:srgbClr val="D05B65"/>
@@ -11862,6 +11995,7 @@
           <a:lstStyle xmlns:a="http://schemas.openxmlformats.org/drawingml/2006/main"/>
           <a:p xmlns:a="http://schemas.openxmlformats.org/drawingml/2006/main">
             <a:pPr algn="l">
+              <a:buNone/>
               <a:defRPr sz="1650" b="0" i="0">
                 <a:solidFill>
                   <a:srgbClr val="163C2C"/>
@@ -11912,6 +12046,7 @@
           <a:lstStyle xmlns:a="http://schemas.openxmlformats.org/drawingml/2006/main"/>
           <a:p xmlns:a="http://schemas.openxmlformats.org/drawingml/2006/main">
             <a:pPr algn="l">
+              <a:buNone/>
               <a:defRPr sz="1275" b="1" i="0">
                 <a:solidFill>
                   <a:srgbClr val="48B985"/>
@@ -11993,6 +12128,7 @@
           <a:lstStyle xmlns:a="http://schemas.openxmlformats.org/drawingml/2006/main"/>
           <a:p xmlns:a="http://schemas.openxmlformats.org/drawingml/2006/main">
             <a:pPr algn="l">
+              <a:buNone/>
               <a:defRPr sz="1650" b="0" i="0">
                 <a:solidFill>
                   <a:srgbClr val="163C2C"/>
@@ -12043,6 +12179,7 @@
           <a:lstStyle xmlns:a="http://schemas.openxmlformats.org/drawingml/2006/main"/>
           <a:p xmlns:a="http://schemas.openxmlformats.org/drawingml/2006/main">
             <a:pPr algn="l">
+              <a:buNone/>
               <a:defRPr sz="1275" b="1" i="0">
                 <a:solidFill>
                   <a:srgbClr val="7FA847"/>
@@ -12124,6 +12261,7 @@
           <a:lstStyle xmlns:a="http://schemas.openxmlformats.org/drawingml/2006/main"/>
           <a:p xmlns:a="http://schemas.openxmlformats.org/drawingml/2006/main">
             <a:pPr algn="l">
+              <a:buNone/>
               <a:defRPr sz="1650" b="0" i="0">
                 <a:solidFill>
                   <a:srgbClr val="163C2C"/>
@@ -12174,6 +12312,7 @@
           <a:lstStyle xmlns:a="http://schemas.openxmlformats.org/drawingml/2006/main"/>
           <a:p xmlns:a="http://schemas.openxmlformats.org/drawingml/2006/main">
             <a:pPr algn="ctr">
+              <a:buNone/>
               <a:defRPr sz="1875" b="1" i="0">
                 <a:solidFill>
                   <a:srgbClr val="48B985"/>
@@ -12286,6 +12425,7 @@
           <a:lstStyle xmlns:a="http://schemas.openxmlformats.org/drawingml/2006/main"/>
           <a:p xmlns:a="http://schemas.openxmlformats.org/drawingml/2006/main">
             <a:pPr algn="l">
+              <a:buNone/>
               <a:defRPr sz="1125" b="1" i="0">
                 <a:solidFill>
                   <a:srgbClr val="48B985"/>
@@ -12336,6 +12476,7 @@
           <a:lstStyle xmlns:a="http://schemas.openxmlformats.org/drawingml/2006/main"/>
           <a:p xmlns:a="http://schemas.openxmlformats.org/drawingml/2006/main">
             <a:pPr algn="l">
+              <a:buNone/>
               <a:defRPr sz="3150" b="1" i="0">
                 <a:solidFill>
                   <a:srgbClr val="163C2C"/>
@@ -12386,6 +12527,7 @@
           <a:lstStyle xmlns:a="http://schemas.openxmlformats.org/drawingml/2006/main"/>
           <a:p xmlns:a="http://schemas.openxmlformats.org/drawingml/2006/main">
             <a:pPr algn="l">
+              <a:buNone/>
               <a:defRPr sz="1500" b="0" i="0">
                 <a:solidFill>
                   <a:srgbClr val="61786E"/>
@@ -12467,6 +12609,7 @@
           <a:lstStyle xmlns:a="http://schemas.openxmlformats.org/drawingml/2006/main"/>
           <a:p xmlns:a="http://schemas.openxmlformats.org/drawingml/2006/main">
             <a:pPr algn="l">
+              <a:buNone/>
               <a:defRPr sz="900" b="1" i="0">
                 <a:solidFill>
                   <a:srgbClr val="7F9389"/>
@@ -12517,6 +12660,7 @@
           <a:lstStyle xmlns:a="http://schemas.openxmlformats.org/drawingml/2006/main"/>
           <a:p xmlns:a="http://schemas.openxmlformats.org/drawingml/2006/main">
             <a:pPr algn="r">
+              <a:buNone/>
               <a:defRPr sz="900" b="1" i="0">
                 <a:solidFill>
                   <a:srgbClr val="7F9389"/>
@@ -12598,6 +12742,7 @@
           <a:lstStyle xmlns:a="http://schemas.openxmlformats.org/drawingml/2006/main"/>
           <a:p xmlns:a="http://schemas.openxmlformats.org/drawingml/2006/main">
             <a:pPr algn="ctr">
+              <a:buNone/>
               <a:defRPr sz="1500" b="1" i="0">
                 <a:solidFill>
                   <a:srgbClr val="F7FBF8"/>
@@ -12648,6 +12793,7 @@
           <a:lstStyle xmlns:a="http://schemas.openxmlformats.org/drawingml/2006/main"/>
           <a:p xmlns:a="http://schemas.openxmlformats.org/drawingml/2006/main">
             <a:pPr algn="l">
+              <a:buNone/>
               <a:defRPr sz="1575" b="1" i="0">
                 <a:solidFill>
                   <a:srgbClr val="163C2C"/>
@@ -12698,6 +12844,7 @@
           <a:lstStyle xmlns:a="http://schemas.openxmlformats.org/drawingml/2006/main"/>
           <a:p xmlns:a="http://schemas.openxmlformats.org/drawingml/2006/main">
             <a:pPr algn="l">
+              <a:buNone/>
               <a:defRPr sz="1425" b="0" i="0">
                 <a:solidFill>
                   <a:srgbClr val="61786E"/>
@@ -12810,6 +12957,7 @@
           <a:lstStyle xmlns:a="http://schemas.openxmlformats.org/drawingml/2006/main"/>
           <a:p xmlns:a="http://schemas.openxmlformats.org/drawingml/2006/main">
             <a:pPr algn="ctr">
+              <a:buNone/>
               <a:defRPr sz="1500" b="1" i="0">
                 <a:solidFill>
                   <a:srgbClr val="F7FBF8"/>
@@ -12860,6 +13008,7 @@
           <a:lstStyle xmlns:a="http://schemas.openxmlformats.org/drawingml/2006/main"/>
           <a:p xmlns:a="http://schemas.openxmlformats.org/drawingml/2006/main">
             <a:pPr algn="l">
+              <a:buNone/>
               <a:defRPr sz="1575" b="1" i="0">
                 <a:solidFill>
                   <a:srgbClr val="163C2C"/>
@@ -12910,6 +13059,7 @@
           <a:lstStyle xmlns:a="http://schemas.openxmlformats.org/drawingml/2006/main"/>
           <a:p xmlns:a="http://schemas.openxmlformats.org/drawingml/2006/main">
             <a:pPr algn="l">
+              <a:buNone/>
               <a:defRPr sz="1425" b="0" i="0">
                 <a:solidFill>
                   <a:srgbClr val="61786E"/>
@@ -13022,6 +13172,7 @@
           <a:lstStyle xmlns:a="http://schemas.openxmlformats.org/drawingml/2006/main"/>
           <a:p xmlns:a="http://schemas.openxmlformats.org/drawingml/2006/main">
             <a:pPr algn="ctr">
+              <a:buNone/>
               <a:defRPr sz="1500" b="1" i="0">
                 <a:solidFill>
                   <a:srgbClr val="F7FBF8"/>
@@ -13072,6 +13223,7 @@
           <a:lstStyle xmlns:a="http://schemas.openxmlformats.org/drawingml/2006/main"/>
           <a:p xmlns:a="http://schemas.openxmlformats.org/drawingml/2006/main">
             <a:pPr algn="l">
+              <a:buNone/>
               <a:defRPr sz="1575" b="1" i="0">
                 <a:solidFill>
                   <a:srgbClr val="163C2C"/>
@@ -13122,6 +13274,7 @@
           <a:lstStyle xmlns:a="http://schemas.openxmlformats.org/drawingml/2006/main"/>
           <a:p xmlns:a="http://schemas.openxmlformats.org/drawingml/2006/main">
             <a:pPr algn="l">
+              <a:buNone/>
               <a:defRPr sz="1425" b="0" i="0">
                 <a:solidFill>
                   <a:srgbClr val="61786E"/>
@@ -13203,6 +13356,7 @@
           <a:lstStyle xmlns:a="http://schemas.openxmlformats.org/drawingml/2006/main"/>
           <a:p xmlns:a="http://schemas.openxmlformats.org/drawingml/2006/main">
             <a:pPr algn="l">
+              <a:buNone/>
               <a:defRPr sz="1200" b="1" i="0">
                 <a:solidFill>
                   <a:srgbClr val="D05B65"/>
@@ -13253,6 +13407,7 @@
           <a:lstStyle xmlns:a="http://schemas.openxmlformats.org/drawingml/2006/main"/>
           <a:p xmlns:a="http://schemas.openxmlformats.org/drawingml/2006/main">
             <a:pPr algn="l">
+              <a:buNone/>
               <a:defRPr sz="2175" b="1" i="0">
                 <a:solidFill>
                   <a:srgbClr val="163C2C"/>
@@ -13338,6 +13493,7 @@
           <a:lstStyle xmlns:a="http://schemas.openxmlformats.org/drawingml/2006/main"/>
           <a:p xmlns:a="http://schemas.openxmlformats.org/drawingml/2006/main">
             <a:pPr algn="ctr">
+              <a:buNone/>
               <a:defRPr sz="2100" b="1" i="0">
                 <a:solidFill>
                   <a:srgbClr val="48B985"/>
@@ -13388,6 +13544,7 @@
           <a:lstStyle xmlns:a="http://schemas.openxmlformats.org/drawingml/2006/main"/>
           <a:p xmlns:a="http://schemas.openxmlformats.org/drawingml/2006/main">
             <a:pPr algn="ctr">
+              <a:buNone/>
               <a:defRPr sz="1350" b="0" i="0">
                 <a:solidFill>
                   <a:srgbClr val="61786E"/>
@@ -13500,6 +13657,7 @@
           <a:lstStyle xmlns:a="http://schemas.openxmlformats.org/drawingml/2006/main"/>
           <a:p xmlns:a="http://schemas.openxmlformats.org/drawingml/2006/main">
             <a:pPr algn="l">
+              <a:buNone/>
               <a:defRPr sz="1125" b="1" i="0">
                 <a:solidFill>
                   <a:srgbClr val="159A64"/>
@@ -13550,6 +13708,7 @@
           <a:lstStyle xmlns:a="http://schemas.openxmlformats.org/drawingml/2006/main"/>
           <a:p xmlns:a="http://schemas.openxmlformats.org/drawingml/2006/main">
             <a:pPr algn="l">
+              <a:buNone/>
               <a:defRPr sz="3150" b="1" i="0">
                 <a:solidFill>
                   <a:srgbClr val="163C2C"/>
@@ -13600,6 +13759,7 @@
           <a:lstStyle xmlns:a="http://schemas.openxmlformats.org/drawingml/2006/main"/>
           <a:p xmlns:a="http://schemas.openxmlformats.org/drawingml/2006/main">
             <a:pPr algn="l">
+              <a:buNone/>
               <a:defRPr sz="1500" b="0" i="0">
                 <a:solidFill>
                   <a:srgbClr val="61786E"/>
@@ -13681,6 +13841,7 @@
           <a:lstStyle xmlns:a="http://schemas.openxmlformats.org/drawingml/2006/main"/>
           <a:p xmlns:a="http://schemas.openxmlformats.org/drawingml/2006/main">
             <a:pPr algn="l">
+              <a:buNone/>
               <a:defRPr sz="900" b="1" i="0">
                 <a:solidFill>
                   <a:srgbClr val="7F9389"/>
@@ -13731,6 +13892,7 @@
           <a:lstStyle xmlns:a="http://schemas.openxmlformats.org/drawingml/2006/main"/>
           <a:p xmlns:a="http://schemas.openxmlformats.org/drawingml/2006/main">
             <a:pPr algn="r">
+              <a:buNone/>
               <a:defRPr sz="900" b="1" i="0">
                 <a:solidFill>
                   <a:srgbClr val="7F9389"/>
@@ -13781,6 +13943,7 @@
           <a:lstStyle xmlns:a="http://schemas.openxmlformats.org/drawingml/2006/main"/>
           <a:p xmlns:a="http://schemas.openxmlformats.org/drawingml/2006/main">
             <a:pPr algn="l">
+              <a:buNone/>
               <a:defRPr sz="1425" b="1" i="0">
                 <a:solidFill>
                   <a:srgbClr val="159A64"/>
@@ -13831,6 +13994,7 @@
           <a:lstStyle xmlns:a="http://schemas.openxmlformats.org/drawingml/2006/main"/>
           <a:p xmlns:a="http://schemas.openxmlformats.org/drawingml/2006/main">
             <a:pPr algn="l">
+              <a:buNone/>
               <a:defRPr sz="1875" b="1" i="0">
                 <a:solidFill>
                   <a:srgbClr val="163C2C"/>
@@ -13881,6 +14045,7 @@
           <a:lstStyle xmlns:a="http://schemas.openxmlformats.org/drawingml/2006/main"/>
           <a:p xmlns:a="http://schemas.openxmlformats.org/drawingml/2006/main">
             <a:pPr algn="l">
+              <a:buNone/>
               <a:defRPr sz="1425" b="1" i="0">
                 <a:solidFill>
                   <a:srgbClr val="48B985"/>
@@ -13931,6 +14096,7 @@
           <a:lstStyle xmlns:a="http://schemas.openxmlformats.org/drawingml/2006/main"/>
           <a:p xmlns:a="http://schemas.openxmlformats.org/drawingml/2006/main">
             <a:pPr algn="l">
+              <a:buNone/>
               <a:defRPr sz="1875" b="1" i="0">
                 <a:solidFill>
                   <a:srgbClr val="163C2C"/>
@@ -13981,6 +14147,7 @@
           <a:lstStyle xmlns:a="http://schemas.openxmlformats.org/drawingml/2006/main"/>
           <a:p xmlns:a="http://schemas.openxmlformats.org/drawingml/2006/main">
             <a:pPr algn="l">
+              <a:buNone/>
               <a:defRPr sz="1425" b="1" i="0">
                 <a:solidFill>
                   <a:srgbClr val="7FA847"/>
@@ -14031,6 +14198,7 @@
           <a:lstStyle xmlns:a="http://schemas.openxmlformats.org/drawingml/2006/main"/>
           <a:p xmlns:a="http://schemas.openxmlformats.org/drawingml/2006/main">
             <a:pPr algn="l">
+              <a:buNone/>
               <a:defRPr sz="1875" b="1" i="0">
                 <a:solidFill>
                   <a:srgbClr val="163C2C"/>
@@ -15102,6 +15270,7 @@
           <a:lstStyle xmlns:a="http://schemas.openxmlformats.org/drawingml/2006/main"/>
           <a:p xmlns:a="http://schemas.openxmlformats.org/drawingml/2006/main">
             <a:pPr algn="ctr">
+              <a:buNone/>
               <a:defRPr sz="2100" b="1" i="0">
                 <a:solidFill>
                   <a:srgbClr val="48B985"/>
@@ -15214,6 +15383,7 @@
           <a:lstStyle xmlns:a="http://schemas.openxmlformats.org/drawingml/2006/main"/>
           <a:p xmlns:a="http://schemas.openxmlformats.org/drawingml/2006/main">
             <a:pPr algn="l">
+              <a:buNone/>
               <a:defRPr sz="1125" b="1" i="0">
                 <a:solidFill>
                   <a:srgbClr val="159A64"/>
@@ -15264,6 +15434,7 @@
           <a:lstStyle xmlns:a="http://schemas.openxmlformats.org/drawingml/2006/main"/>
           <a:p xmlns:a="http://schemas.openxmlformats.org/drawingml/2006/main">
             <a:pPr algn="l">
+              <a:buNone/>
               <a:defRPr sz="3150" b="1" i="0">
                 <a:solidFill>
                   <a:srgbClr val="163C2C"/>
@@ -15314,6 +15485,7 @@
           <a:lstStyle xmlns:a="http://schemas.openxmlformats.org/drawingml/2006/main"/>
           <a:p xmlns:a="http://schemas.openxmlformats.org/drawingml/2006/main">
             <a:pPr algn="l">
+              <a:buNone/>
               <a:defRPr sz="1500" b="0" i="0">
                 <a:solidFill>
                   <a:srgbClr val="61786E"/>
@@ -15395,6 +15567,7 @@
           <a:lstStyle xmlns:a="http://schemas.openxmlformats.org/drawingml/2006/main"/>
           <a:p xmlns:a="http://schemas.openxmlformats.org/drawingml/2006/main">
             <a:pPr algn="l">
+              <a:buNone/>
               <a:defRPr sz="900" b="1" i="0">
                 <a:solidFill>
                   <a:srgbClr val="7F9389"/>
@@ -15445,6 +15618,7 @@
           <a:lstStyle xmlns:a="http://schemas.openxmlformats.org/drawingml/2006/main"/>
           <a:p xmlns:a="http://schemas.openxmlformats.org/drawingml/2006/main">
             <a:pPr algn="r">
+              <a:buNone/>
               <a:defRPr sz="900" b="1" i="0">
                 <a:solidFill>
                   <a:srgbClr val="7F9389"/>
@@ -15495,6 +15669,7 @@
           <a:lstStyle xmlns:a="http://schemas.openxmlformats.org/drawingml/2006/main"/>
           <a:p xmlns:a="http://schemas.openxmlformats.org/drawingml/2006/main">
             <a:pPr algn="l">
+              <a:buNone/>
               <a:defRPr sz="2550" b="1" i="0">
                 <a:solidFill>
                   <a:srgbClr val="163C2C"/>
@@ -15545,6 +15720,7 @@
           <a:lstStyle xmlns:a="http://schemas.openxmlformats.org/drawingml/2006/main"/>
           <a:p xmlns:a="http://schemas.openxmlformats.org/drawingml/2006/main">
             <a:pPr algn="l">
+              <a:buNone/>
               <a:defRPr sz="1575" b="0" i="0">
                 <a:solidFill>
                   <a:srgbClr val="61786E"/>
@@ -15595,6 +15771,7 @@
           <a:lstStyle xmlns:a="http://schemas.openxmlformats.org/drawingml/2006/main"/>
           <a:p xmlns:a="http://schemas.openxmlformats.org/drawingml/2006/main">
             <a:pPr algn="l">
+              <a:buNone/>
               <a:defRPr sz="2550" b="1" i="0">
                 <a:solidFill>
                   <a:srgbClr val="48B985"/>
@@ -16208,6 +16385,7 @@
           <a:lstStyle xmlns:a="http://schemas.openxmlformats.org/drawingml/2006/main"/>
           <a:p xmlns:a="http://schemas.openxmlformats.org/drawingml/2006/main">
             <a:pPr algn="ctr">
+              <a:buNone/>
               <a:defRPr sz="1350" b="1" i="0">
                 <a:solidFill>
                   <a:srgbClr val="D05B65"/>
@@ -16258,6 +16436,7 @@
           <a:lstStyle xmlns:a="http://schemas.openxmlformats.org/drawingml/2006/main"/>
           <a:p xmlns:a="http://schemas.openxmlformats.org/drawingml/2006/main">
             <a:pPr algn="l">
+              <a:buNone/>
               <a:defRPr sz="1200" b="1" i="0">
                 <a:solidFill>
                   <a:srgbClr val="159A64"/>
@@ -16308,6 +16487,7 @@
           <a:lstStyle xmlns:a="http://schemas.openxmlformats.org/drawingml/2006/main"/>
           <a:p xmlns:a="http://schemas.openxmlformats.org/drawingml/2006/main">
             <a:pPr algn="l">
+              <a:buNone/>
               <a:defRPr sz="1575" b="0" i="0">
                 <a:solidFill>
                   <a:srgbClr val="163C2C"/>
@@ -16420,6 +16600,7 @@
           <a:lstStyle xmlns:a="http://schemas.openxmlformats.org/drawingml/2006/main"/>
           <a:p xmlns:a="http://schemas.openxmlformats.org/drawingml/2006/main">
             <a:pPr algn="l">
+              <a:buNone/>
               <a:defRPr sz="1125" b="1" i="0">
                 <a:solidFill>
                   <a:srgbClr val="7FA847"/>
@@ -16470,6 +16651,7 @@
           <a:lstStyle xmlns:a="http://schemas.openxmlformats.org/drawingml/2006/main"/>
           <a:p xmlns:a="http://schemas.openxmlformats.org/drawingml/2006/main">
             <a:pPr algn="l">
+              <a:buNone/>
               <a:defRPr sz="3150" b="1" i="0">
                 <a:solidFill>
                   <a:srgbClr val="163C2C"/>
@@ -16520,6 +16702,7 @@
           <a:lstStyle xmlns:a="http://schemas.openxmlformats.org/drawingml/2006/main"/>
           <a:p xmlns:a="http://schemas.openxmlformats.org/drawingml/2006/main">
             <a:pPr algn="l">
+              <a:buNone/>
               <a:defRPr sz="1500" b="0" i="0">
                 <a:solidFill>
                   <a:srgbClr val="61786E"/>
@@ -16601,6 +16784,7 @@
           <a:lstStyle xmlns:a="http://schemas.openxmlformats.org/drawingml/2006/main"/>
           <a:p xmlns:a="http://schemas.openxmlformats.org/drawingml/2006/main">
             <a:pPr algn="l">
+              <a:buNone/>
               <a:defRPr sz="900" b="1" i="0">
                 <a:solidFill>
                   <a:srgbClr val="7F9389"/>
@@ -16651,6 +16835,7 @@
           <a:lstStyle xmlns:a="http://schemas.openxmlformats.org/drawingml/2006/main"/>
           <a:p xmlns:a="http://schemas.openxmlformats.org/drawingml/2006/main">
             <a:pPr algn="r">
+              <a:buNone/>
               <a:defRPr sz="900" b="1" i="0">
                 <a:solidFill>
                   <a:srgbClr val="7F9389"/>
@@ -16765,6 +16950,7 @@
           <a:lstStyle xmlns:a="http://schemas.openxmlformats.org/drawingml/2006/main"/>
           <a:p xmlns:a="http://schemas.openxmlformats.org/drawingml/2006/main">
             <a:pPr algn="ctr">
+              <a:buNone/>
               <a:defRPr sz="1350" b="1" i="0">
                 <a:solidFill>
                   <a:srgbClr val="F7FBF8"/>
@@ -16886,6 +17072,7 @@
           <a:lstStyle xmlns:a="http://schemas.openxmlformats.org/drawingml/2006/main"/>
           <a:p xmlns:a="http://schemas.openxmlformats.org/drawingml/2006/main">
             <a:pPr algn="ctr">
+              <a:buNone/>
               <a:defRPr sz="1350" b="1" i="0">
                 <a:solidFill>
                   <a:srgbClr val="F7FBF8"/>
@@ -17007,6 +17194,7 @@
           <a:lstStyle xmlns:a="http://schemas.openxmlformats.org/drawingml/2006/main"/>
           <a:p xmlns:a="http://schemas.openxmlformats.org/drawingml/2006/main">
             <a:pPr algn="ctr">
+              <a:buNone/>
               <a:defRPr sz="1350" b="1" i="0">
                 <a:solidFill>
                   <a:srgbClr val="F7FBF8"/>
@@ -17128,6 +17316,7 @@
           <a:lstStyle xmlns:a="http://schemas.openxmlformats.org/drawingml/2006/main"/>
           <a:p xmlns:a="http://schemas.openxmlformats.org/drawingml/2006/main">
             <a:pPr algn="ctr">
+              <a:buNone/>
               <a:defRPr sz="1350" b="1" i="0">
                 <a:solidFill>
                   <a:srgbClr val="F7FBF8"/>
@@ -17216,6 +17405,7 @@
           <a:lstStyle xmlns:a="http://schemas.openxmlformats.org/drawingml/2006/main"/>
           <a:p xmlns:a="http://schemas.openxmlformats.org/drawingml/2006/main">
             <a:pPr algn="ctr">
+              <a:buNone/>
               <a:defRPr sz="1575" b="1" i="0">
                 <a:solidFill>
                   <a:srgbClr val="163C2C"/>
@@ -17266,6 +17456,7 @@
           <a:lstStyle xmlns:a="http://schemas.openxmlformats.org/drawingml/2006/main"/>
           <a:p xmlns:a="http://schemas.openxmlformats.org/drawingml/2006/main">
             <a:pPr algn="ctr">
+              <a:buNone/>
               <a:defRPr sz="1575" b="1" i="0">
                 <a:solidFill>
                   <a:srgbClr val="163C2C"/>
@@ -17316,6 +17507,7 @@
           <a:lstStyle xmlns:a="http://schemas.openxmlformats.org/drawingml/2006/main"/>
           <a:p xmlns:a="http://schemas.openxmlformats.org/drawingml/2006/main">
             <a:pPr algn="ctr">
+              <a:buNone/>
               <a:defRPr sz="1575" b="1" i="0">
                 <a:solidFill>
                   <a:srgbClr val="163C2C"/>
@@ -17366,6 +17558,7 @@
           <a:lstStyle xmlns:a="http://schemas.openxmlformats.org/drawingml/2006/main"/>
           <a:p xmlns:a="http://schemas.openxmlformats.org/drawingml/2006/main">
             <a:pPr algn="ctr">
+              <a:buNone/>
               <a:defRPr sz="1575" b="1" i="0">
                 <a:solidFill>
                   <a:srgbClr val="163C2C"/>
@@ -17416,6 +17609,7 @@
           <a:lstStyle xmlns:a="http://schemas.openxmlformats.org/drawingml/2006/main"/>
           <a:p xmlns:a="http://schemas.openxmlformats.org/drawingml/2006/main">
             <a:pPr algn="ctr">
+              <a:buNone/>
               <a:defRPr sz="2100" b="1" i="0">
                 <a:solidFill>
                   <a:srgbClr val="48B985"/>
@@ -17528,6 +17722,7 @@
           <a:lstStyle xmlns:a="http://schemas.openxmlformats.org/drawingml/2006/main"/>
           <a:p xmlns:a="http://schemas.openxmlformats.org/drawingml/2006/main">
             <a:pPr algn="l">
+              <a:buNone/>
               <a:defRPr sz="1125" b="1" i="0">
                 <a:solidFill>
                   <a:srgbClr val="48B985"/>
@@ -17578,6 +17773,7 @@
           <a:lstStyle xmlns:a="http://schemas.openxmlformats.org/drawingml/2006/main"/>
           <a:p xmlns:a="http://schemas.openxmlformats.org/drawingml/2006/main">
             <a:pPr algn="l">
+              <a:buNone/>
               <a:defRPr sz="3150" b="1" i="0">
                 <a:solidFill>
                   <a:srgbClr val="163C2C"/>
@@ -17628,6 +17824,7 @@
           <a:lstStyle xmlns:a="http://schemas.openxmlformats.org/drawingml/2006/main"/>
           <a:p xmlns:a="http://schemas.openxmlformats.org/drawingml/2006/main">
             <a:pPr algn="l">
+              <a:buNone/>
               <a:defRPr sz="1500" b="0" i="0">
                 <a:solidFill>
                   <a:srgbClr val="61786E"/>
@@ -17709,6 +17906,7 @@
           <a:lstStyle xmlns:a="http://schemas.openxmlformats.org/drawingml/2006/main"/>
           <a:p xmlns:a="http://schemas.openxmlformats.org/drawingml/2006/main">
             <a:pPr algn="l">
+              <a:buNone/>
               <a:defRPr sz="900" b="1" i="0">
                 <a:solidFill>
                   <a:srgbClr val="7F9389"/>
@@ -17759,6 +17957,7 @@
           <a:lstStyle xmlns:a="http://schemas.openxmlformats.org/drawingml/2006/main"/>
           <a:p xmlns:a="http://schemas.openxmlformats.org/drawingml/2006/main">
             <a:pPr algn="r">
+              <a:buNone/>
               <a:defRPr sz="900" b="1" i="0">
                 <a:solidFill>
                   <a:srgbClr val="7F9389"/>
@@ -17970,6 +18169,7 @@
           <a:lstStyle xmlns:a="http://schemas.openxmlformats.org/drawingml/2006/main"/>
           <a:p xmlns:a="http://schemas.openxmlformats.org/drawingml/2006/main">
             <a:pPr algn="l">
+              <a:buNone/>
               <a:defRPr sz="1200" b="0" i="0">
                 <a:solidFill>
                   <a:srgbClr val="F7FBF8"/>
@@ -17992,6 +18192,7 @@
           </a:p>
           <a:p xmlns:a="http://schemas.openxmlformats.org/drawingml/2006/main">
             <a:pPr algn="l">
+              <a:buNone/>
               <a:defRPr sz="1200" b="0" i="0">
                 <a:solidFill>
                   <a:srgbClr val="F7FBF8"/>
@@ -18014,6 +18215,7 @@
           </a:p>
           <a:p xmlns:a="http://schemas.openxmlformats.org/drawingml/2006/main">
             <a:pPr algn="l">
+              <a:buNone/>
               <a:defRPr sz="1200" b="0" i="0">
                 <a:solidFill>
                   <a:srgbClr val="F7FBF8"/>
@@ -18031,6 +18233,7 @@
           </a:p>
           <a:p xmlns:a="http://schemas.openxmlformats.org/drawingml/2006/main">
             <a:pPr algn="l">
+              <a:buNone/>
               <a:defRPr sz="1200" b="0" i="0">
                 <a:solidFill>
                   <a:srgbClr val="F7FBF8"/>
@@ -18081,6 +18284,7 @@
           <a:lstStyle xmlns:a="http://schemas.openxmlformats.org/drawingml/2006/main"/>
           <a:p xmlns:a="http://schemas.openxmlformats.org/drawingml/2006/main">
             <a:pPr algn="l">
+              <a:buNone/>
               <a:defRPr sz="2250" b="1" i="0">
                 <a:solidFill>
                   <a:srgbClr val="159A64"/>
@@ -18115,7 +18319,7 @@
         <p:spPr>
           <a:xfrm xmlns:a="http://schemas.openxmlformats.org/drawingml/2006/main">
             <a:off x="4667250" y="2305050"/>
-            <a:ext cx="5334000" cy="323850"/>
+            <a:ext cx="3714750" cy="323850"/>
           </a:xfrm>
           <a:prstGeom xmlns:a="http://schemas.openxmlformats.org/drawingml/2006/main" prst="rect">
             <a:avLst/>
@@ -18131,6 +18335,7 @@
           <a:lstStyle xmlns:a="http://schemas.openxmlformats.org/drawingml/2006/main"/>
           <a:p xmlns:a="http://schemas.openxmlformats.org/drawingml/2006/main">
             <a:pPr algn="l">
+              <a:buNone/>
               <a:defRPr sz="1800" b="1" i="0">
                 <a:solidFill>
                   <a:srgbClr val="163C2C"/>
@@ -18143,7 +18348,7 @@
                   <a:srgbClr val="163C2C"/>
                 </a:solidFill>
               </a:rPr>
-              <a:t>Open the workshop repo</a:t>
+              <a:t>Open the workshop repository</a:t>
             </a:r>
           </a:p>
         </p:txBody>
@@ -18181,6 +18386,7 @@
           <a:lstStyle xmlns:a="http://schemas.openxmlformats.org/drawingml/2006/main"/>
           <a:p xmlns:a="http://schemas.openxmlformats.org/drawingml/2006/main">
             <a:pPr algn="l">
+              <a:buNone/>
               <a:defRPr sz="2250" b="1" i="0">
                 <a:solidFill>
                   <a:srgbClr val="159A64"/>
@@ -18215,7 +18421,7 @@
         <p:spPr>
           <a:xfrm xmlns:a="http://schemas.openxmlformats.org/drawingml/2006/main">
             <a:off x="4667250" y="3124200"/>
-            <a:ext cx="6191250" cy="323850"/>
+            <a:ext cx="3714750" cy="323850"/>
           </a:xfrm>
           <a:prstGeom xmlns:a="http://schemas.openxmlformats.org/drawingml/2006/main" prst="rect">
             <a:avLst/>
@@ -18231,6 +18437,7 @@
           <a:lstStyle xmlns:a="http://schemas.openxmlformats.org/drawingml/2006/main"/>
           <a:p xmlns:a="http://schemas.openxmlformats.org/drawingml/2006/main">
             <a:pPr algn="l">
+              <a:buNone/>
               <a:defRPr sz="1800" b="1" i="0">
                 <a:solidFill>
                   <a:srgbClr val="163C2C"/>
@@ -18243,7 +18450,7 @@
                   <a:srgbClr val="163C2C"/>
                 </a:solidFill>
               </a:rPr>
-              <a:t>Use the prepared environment + API key</a:t>
+              <a:t>Add your AI Studio API key</a:t>
             </a:r>
           </a:p>
         </p:txBody>
@@ -18281,6 +18488,7 @@
           <a:lstStyle xmlns:a="http://schemas.openxmlformats.org/drawingml/2006/main"/>
           <a:p xmlns:a="http://schemas.openxmlformats.org/drawingml/2006/main">
             <a:pPr algn="l">
+              <a:buNone/>
               <a:defRPr sz="2250" b="1" i="0">
                 <a:solidFill>
                   <a:srgbClr val="159A64"/>
@@ -18315,7 +18523,7 @@
         <p:spPr>
           <a:xfrm xmlns:a="http://schemas.openxmlformats.org/drawingml/2006/main">
             <a:off x="4667250" y="3943350"/>
-            <a:ext cx="6191250" cy="323850"/>
+            <a:ext cx="3714750" cy="323850"/>
           </a:xfrm>
           <a:prstGeom xmlns:a="http://schemas.openxmlformats.org/drawingml/2006/main" prst="rect">
             <a:avLst/>
@@ -18331,6 +18539,7 @@
           <a:lstStyle xmlns:a="http://schemas.openxmlformats.org/drawingml/2006/main"/>
           <a:p xmlns:a="http://schemas.openxmlformats.org/drawingml/2006/main">
             <a:pPr algn="l">
+              <a:buNone/>
               <a:defRPr sz="1800" b="1" i="0">
                 <a:solidFill>
                   <a:srgbClr val="163C2C"/>
@@ -18416,6 +18625,7 @@
           <a:lstStyle xmlns:a="http://schemas.openxmlformats.org/drawingml/2006/main"/>
           <a:p xmlns:a="http://schemas.openxmlformats.org/drawingml/2006/main">
             <a:pPr algn="l">
+              <a:buNone/>
               <a:defRPr sz="1500" b="1" i="0">
                 <a:solidFill>
                   <a:srgbClr val="48B985"/>
@@ -18429,6 +18639,96 @@
                 </a:solidFill>
               </a:rPr>
               <a:t>Stuck? Jump to the next checkpoint folder and keep moving.</a:t>
+            </a:r>
+          </a:p>
+        </p:txBody>
+      </p:sp>
+      <p:pic>
+        <p:nvPicPr>
+          <p:cNvPr id="46" name=""/>
+          <p:cNvPicPr>
+            <a:picLocks xmlns:a="http://schemas.openxmlformats.org/drawingml/2006/main" noChangeAspect="1"/>
+          </p:cNvPicPr>
+          <p:nvPr/>
+        </p:nvPicPr>
+        <p:blipFill>
+          <a:blip xmlns:r="http://schemas.openxmlformats.org/officeDocument/2006/relationships" xmlns:a="http://schemas.openxmlformats.org/drawingml/2006/main" r:embed="Ra3fde7d295294840"/>
+          <a:stretch xmlns:a="http://schemas.openxmlformats.org/drawingml/2006/main"/>
+        </p:blipFill>
+        <p:spPr>
+          <a:xfrm xmlns:a="http://schemas.openxmlformats.org/drawingml/2006/main">
+            <a:off x="9067800" y="2209800"/>
+            <a:ext cx="1600200" cy="1600200"/>
+          </a:xfrm>
+          <a:prstGeom xmlns:a="http://schemas.openxmlformats.org/drawingml/2006/main" prst="rect">
+            <a:avLst/>
+          </a:prstGeom>
+        </p:spPr>
+      </p:pic>
+      <p:sp>
+        <p:nvSpPr>
+          <p:cNvPr id="24" name="workshop-repository-link">
+            <a:extLst xmlns:a="http://schemas.openxmlformats.org/drawingml/2006/main">
+              <a:ext uri="{FF2B5EF4-FFF2-40B4-BE49-F238E27FC236}">
+                <a16:creationId xmlns:a16="http://schemas.microsoft.com/office/drawing/2014/main" id="{9287FA24-3A39-4CD5-8357-28D46DE861D1}"/>
+              </a:ext>
+            </a:extLst>
+          </p:cNvPr>
+          <p:cNvSpPr>
+            <a:spLocks xmlns:a="http://schemas.openxmlformats.org/drawingml/2006/main" noGrp="1"/>
+          </p:cNvSpPr>
+          <p:nvPr/>
+        </p:nvSpPr>
+        <p:spPr>
+          <a:xfrm xmlns:a="http://schemas.openxmlformats.org/drawingml/2006/main">
+            <a:off x="8382000" y="3943350"/>
+            <a:ext cx="2895600" cy="533400"/>
+          </a:xfrm>
+          <a:prstGeom xmlns:a="http://schemas.openxmlformats.org/drawingml/2006/main" prst="rect">
+            <a:avLst/>
+          </a:prstGeom>
+          <a:noFill xmlns:a="http://schemas.openxmlformats.org/drawingml/2006/main"/>
+          <a:ln xmlns:a="http://schemas.openxmlformats.org/drawingml/2006/main" w="0">
+            <a:noFill/>
+            <a:prstDash val="solid"/>
+          </a:ln>
+        </p:spPr>
+        <p:txBody>
+          <a:bodyPr xmlns:a="http://schemas.openxmlformats.org/drawingml/2006/main" anchor="ctr"/>
+          <a:lstStyle xmlns:a="http://schemas.openxmlformats.org/drawingml/2006/main"/>
+          <a:p xmlns:a="http://schemas.openxmlformats.org/drawingml/2006/main">
+            <a:pPr algn="ctr">
+              <a:defRPr sz="900" b="1">
+                <a:solidFill>
+                  <a:srgbClr val="159A64"/>
+                </a:solidFill>
+              </a:defRPr>
+            </a:pPr>
+            <a:r>
+              <a:rPr sz="900" b="1">
+                <a:solidFill>
+                  <a:srgbClr val="159A64"/>
+                </a:solidFill>
+              </a:rPr>
+              <a:t>SCAN TO OPEN</a:t>
+            </a:r>
+          </a:p>
+          <a:p xmlns:a="http://schemas.openxmlformats.org/drawingml/2006/main">
+            <a:pPr algn="ctr">
+              <a:defRPr sz="900" b="1">
+                <a:solidFill>
+                  <a:srgbClr val="159A64"/>
+                </a:solidFill>
+              </a:defRPr>
+            </a:pPr>
+            <a:r>
+              <a:rPr sz="900" b="1">
+                <a:solidFill>
+                  <a:srgbClr val="159A64"/>
+                </a:solidFill>
+                <a:hlinkClick xmlns:r="http://schemas.openxmlformats.org/officeDocument/2006/relationships" r:id="R2bc4222718734fab"/>
+              </a:rPr>
+              <a:t>github.com/aswincsekar/adk-voice-workshop</a:t>
             </a:r>
           </a:p>
         </p:txBody>
@@ -18528,6 +18828,7 @@
           <a:lstStyle xmlns:a="http://schemas.openxmlformats.org/drawingml/2006/main"/>
           <a:p xmlns:a="http://schemas.openxmlformats.org/drawingml/2006/main">
             <a:pPr algn="l">
+              <a:buNone/>
               <a:defRPr sz="1125" b="1" i="0">
                 <a:solidFill>
                   <a:srgbClr val="7FA847"/>
@@ -18578,6 +18879,7 @@
           <a:lstStyle xmlns:a="http://schemas.openxmlformats.org/drawingml/2006/main"/>
           <a:p xmlns:a="http://schemas.openxmlformats.org/drawingml/2006/main">
             <a:pPr algn="l">
+              <a:buNone/>
               <a:defRPr sz="3150" b="1" i="0">
                 <a:solidFill>
                   <a:srgbClr val="163C2C"/>
@@ -18628,6 +18930,7 @@
           <a:lstStyle xmlns:a="http://schemas.openxmlformats.org/drawingml/2006/main"/>
           <a:p xmlns:a="http://schemas.openxmlformats.org/drawingml/2006/main">
             <a:pPr algn="l">
+              <a:buNone/>
               <a:defRPr sz="1500" b="0" i="0">
                 <a:solidFill>
                   <a:srgbClr val="61786E"/>
@@ -18709,6 +19012,7 @@
           <a:lstStyle xmlns:a="http://schemas.openxmlformats.org/drawingml/2006/main"/>
           <a:p xmlns:a="http://schemas.openxmlformats.org/drawingml/2006/main">
             <a:pPr algn="l">
+              <a:buNone/>
               <a:defRPr sz="900" b="1" i="0">
                 <a:solidFill>
                   <a:srgbClr val="7F9389"/>
@@ -18759,6 +19063,7 @@
           <a:lstStyle xmlns:a="http://schemas.openxmlformats.org/drawingml/2006/main"/>
           <a:p xmlns:a="http://schemas.openxmlformats.org/drawingml/2006/main">
             <a:pPr algn="r">
+              <a:buNone/>
               <a:defRPr sz="900" b="1" i="0">
                 <a:solidFill>
                   <a:srgbClr val="7F9389"/>
@@ -18871,6 +19176,7 @@
           <a:lstStyle xmlns:a="http://schemas.openxmlformats.org/drawingml/2006/main"/>
           <a:p xmlns:a="http://schemas.openxmlformats.org/drawingml/2006/main">
             <a:pPr algn="ctr">
+              <a:buNone/>
               <a:defRPr sz="1200" b="1" i="0">
                 <a:solidFill>
                   <a:srgbClr val="F7FBF8"/>
@@ -18921,6 +19227,7 @@
           <a:lstStyle xmlns:a="http://schemas.openxmlformats.org/drawingml/2006/main"/>
           <a:p xmlns:a="http://schemas.openxmlformats.org/drawingml/2006/main">
             <a:pPr algn="ctr">
+              <a:buNone/>
               <a:defRPr sz="1275" b="1" i="0">
                 <a:solidFill>
                   <a:srgbClr val="163C2C"/>
@@ -18971,6 +19278,7 @@
           <a:lstStyle xmlns:a="http://schemas.openxmlformats.org/drawingml/2006/main"/>
           <a:p xmlns:a="http://schemas.openxmlformats.org/drawingml/2006/main">
             <a:pPr algn="ctr">
+              <a:buNone/>
               <a:defRPr sz="1125" b="0" i="0">
                 <a:solidFill>
                   <a:srgbClr val="61786E"/>
@@ -19052,6 +19360,7 @@
           <a:lstStyle xmlns:a="http://schemas.openxmlformats.org/drawingml/2006/main"/>
           <a:p xmlns:a="http://schemas.openxmlformats.org/drawingml/2006/main">
             <a:pPr algn="ctr">
+              <a:buNone/>
               <a:defRPr sz="1200" b="1" i="0">
                 <a:solidFill>
                   <a:srgbClr val="F7FBF8"/>
@@ -19102,6 +19411,7 @@
           <a:lstStyle xmlns:a="http://schemas.openxmlformats.org/drawingml/2006/main"/>
           <a:p xmlns:a="http://schemas.openxmlformats.org/drawingml/2006/main">
             <a:pPr algn="ctr">
+              <a:buNone/>
               <a:defRPr sz="1275" b="1" i="0">
                 <a:solidFill>
                   <a:srgbClr val="163C2C"/>
@@ -19152,6 +19462,7 @@
           <a:lstStyle xmlns:a="http://schemas.openxmlformats.org/drawingml/2006/main"/>
           <a:p xmlns:a="http://schemas.openxmlformats.org/drawingml/2006/main">
             <a:pPr algn="ctr">
+              <a:buNone/>
               <a:defRPr sz="1125" b="0" i="0">
                 <a:solidFill>
                   <a:srgbClr val="61786E"/>
@@ -19233,6 +19544,7 @@
           <a:lstStyle xmlns:a="http://schemas.openxmlformats.org/drawingml/2006/main"/>
           <a:p xmlns:a="http://schemas.openxmlformats.org/drawingml/2006/main">
             <a:pPr algn="ctr">
+              <a:buNone/>
               <a:defRPr sz="1200" b="1" i="0">
                 <a:solidFill>
                   <a:srgbClr val="F7FBF8"/>
@@ -19283,6 +19595,7 @@
           <a:lstStyle xmlns:a="http://schemas.openxmlformats.org/drawingml/2006/main"/>
           <a:p xmlns:a="http://schemas.openxmlformats.org/drawingml/2006/main">
             <a:pPr algn="ctr">
+              <a:buNone/>
               <a:defRPr sz="1275" b="1" i="0">
                 <a:solidFill>
                   <a:srgbClr val="163C2C"/>
@@ -19333,6 +19646,7 @@
           <a:lstStyle xmlns:a="http://schemas.openxmlformats.org/drawingml/2006/main"/>
           <a:p xmlns:a="http://schemas.openxmlformats.org/drawingml/2006/main">
             <a:pPr algn="ctr">
+              <a:buNone/>
               <a:defRPr sz="1125" b="0" i="0">
                 <a:solidFill>
                   <a:srgbClr val="61786E"/>
@@ -19414,6 +19728,7 @@
           <a:lstStyle xmlns:a="http://schemas.openxmlformats.org/drawingml/2006/main"/>
           <a:p xmlns:a="http://schemas.openxmlformats.org/drawingml/2006/main">
             <a:pPr algn="ctr">
+              <a:buNone/>
               <a:defRPr sz="1200" b="1" i="0">
                 <a:solidFill>
                   <a:srgbClr val="F7FBF8"/>
@@ -19464,6 +19779,7 @@
           <a:lstStyle xmlns:a="http://schemas.openxmlformats.org/drawingml/2006/main"/>
           <a:p xmlns:a="http://schemas.openxmlformats.org/drawingml/2006/main">
             <a:pPr algn="ctr">
+              <a:buNone/>
               <a:defRPr sz="1275" b="1" i="0">
                 <a:solidFill>
                   <a:srgbClr val="163C2C"/>
@@ -19514,6 +19830,7 @@
           <a:lstStyle xmlns:a="http://schemas.openxmlformats.org/drawingml/2006/main"/>
           <a:p xmlns:a="http://schemas.openxmlformats.org/drawingml/2006/main">
             <a:pPr algn="ctr">
+              <a:buNone/>
               <a:defRPr sz="1125" b="0" i="0">
                 <a:solidFill>
                   <a:srgbClr val="61786E"/>
@@ -19595,6 +19912,7 @@
           <a:lstStyle xmlns:a="http://schemas.openxmlformats.org/drawingml/2006/main"/>
           <a:p xmlns:a="http://schemas.openxmlformats.org/drawingml/2006/main">
             <a:pPr algn="ctr">
+              <a:buNone/>
               <a:defRPr sz="1200" b="1" i="0">
                 <a:solidFill>
                   <a:srgbClr val="F7FBF8"/>
@@ -19645,6 +19963,7 @@
           <a:lstStyle xmlns:a="http://schemas.openxmlformats.org/drawingml/2006/main"/>
           <a:p xmlns:a="http://schemas.openxmlformats.org/drawingml/2006/main">
             <a:pPr algn="ctr">
+              <a:buNone/>
               <a:defRPr sz="1275" b="1" i="0">
                 <a:solidFill>
                   <a:srgbClr val="163C2C"/>
@@ -19695,6 +20014,7 @@
           <a:lstStyle xmlns:a="http://schemas.openxmlformats.org/drawingml/2006/main"/>
           <a:p xmlns:a="http://schemas.openxmlformats.org/drawingml/2006/main">
             <a:pPr algn="ctr">
+              <a:buNone/>
               <a:defRPr sz="1125" b="0" i="0">
                 <a:solidFill>
                   <a:srgbClr val="61786E"/>
@@ -19776,6 +20096,7 @@
           <a:lstStyle xmlns:a="http://schemas.openxmlformats.org/drawingml/2006/main"/>
           <a:p xmlns:a="http://schemas.openxmlformats.org/drawingml/2006/main">
             <a:pPr algn="ctr">
+              <a:buNone/>
               <a:defRPr sz="1200" b="1" i="0">
                 <a:solidFill>
                   <a:srgbClr val="F7FBF8"/>
@@ -19826,6 +20147,7 @@
           <a:lstStyle xmlns:a="http://schemas.openxmlformats.org/drawingml/2006/main"/>
           <a:p xmlns:a="http://schemas.openxmlformats.org/drawingml/2006/main">
             <a:pPr algn="ctr">
+              <a:buNone/>
               <a:defRPr sz="1275" b="1" i="0">
                 <a:solidFill>
                   <a:srgbClr val="163C2C"/>
@@ -19876,6 +20198,7 @@
           <a:lstStyle xmlns:a="http://schemas.openxmlformats.org/drawingml/2006/main"/>
           <a:p xmlns:a="http://schemas.openxmlformats.org/drawingml/2006/main">
             <a:pPr algn="ctr">
+              <a:buNone/>
               <a:defRPr sz="1125" b="0" i="0">
                 <a:solidFill>
                   <a:srgbClr val="61786E"/>
@@ -19926,6 +20249,7 @@
           <a:lstStyle xmlns:a="http://schemas.openxmlformats.org/drawingml/2006/main"/>
           <a:p xmlns:a="http://schemas.openxmlformats.org/drawingml/2006/main">
             <a:pPr algn="ctr">
+              <a:buNone/>
               <a:defRPr sz="1800" b="1" i="0">
                 <a:solidFill>
                   <a:srgbClr val="48B985"/>
@@ -20038,6 +20362,7 @@
           <a:lstStyle xmlns:a="http://schemas.openxmlformats.org/drawingml/2006/main"/>
           <a:p xmlns:a="http://schemas.openxmlformats.org/drawingml/2006/main">
             <a:pPr algn="l">
+              <a:buNone/>
               <a:defRPr sz="1125" b="1" i="0">
                 <a:solidFill>
                   <a:srgbClr val="7FA847"/>
@@ -20088,6 +20413,7 @@
           <a:lstStyle xmlns:a="http://schemas.openxmlformats.org/drawingml/2006/main"/>
           <a:p xmlns:a="http://schemas.openxmlformats.org/drawingml/2006/main">
             <a:pPr algn="l">
+              <a:buNone/>
               <a:defRPr sz="3150" b="1" i="0">
                 <a:solidFill>
                   <a:srgbClr val="163C2C"/>
@@ -20138,6 +20464,7 @@
           <a:lstStyle xmlns:a="http://schemas.openxmlformats.org/drawingml/2006/main"/>
           <a:p xmlns:a="http://schemas.openxmlformats.org/drawingml/2006/main">
             <a:pPr algn="l">
+              <a:buNone/>
               <a:defRPr sz="1500" b="0" i="0">
                 <a:solidFill>
                   <a:srgbClr val="61786E"/>
@@ -20219,6 +20546,7 @@
           <a:lstStyle xmlns:a="http://schemas.openxmlformats.org/drawingml/2006/main"/>
           <a:p xmlns:a="http://schemas.openxmlformats.org/drawingml/2006/main">
             <a:pPr algn="l">
+              <a:buNone/>
               <a:defRPr sz="900" b="1" i="0">
                 <a:solidFill>
                   <a:srgbClr val="7F9389"/>
@@ -20269,6 +20597,7 @@
           <a:lstStyle xmlns:a="http://schemas.openxmlformats.org/drawingml/2006/main"/>
           <a:p xmlns:a="http://schemas.openxmlformats.org/drawingml/2006/main">
             <a:pPr algn="r">
+              <a:buNone/>
               <a:defRPr sz="900" b="1" i="0">
                 <a:solidFill>
                   <a:srgbClr val="7F9389"/>
@@ -20480,6 +20809,7 @@
           <a:lstStyle xmlns:a="http://schemas.openxmlformats.org/drawingml/2006/main"/>
           <a:p xmlns:a="http://schemas.openxmlformats.org/drawingml/2006/main">
             <a:pPr algn="l">
+              <a:buNone/>
               <a:defRPr sz="1200" b="0" i="0">
                 <a:solidFill>
                   <a:srgbClr val="F7FBF8"/>
@@ -20497,6 +20827,7 @@
           </a:p>
           <a:p xmlns:a="http://schemas.openxmlformats.org/drawingml/2006/main">
             <a:pPr algn="l">
+              <a:buNone/>
               <a:defRPr sz="1200" b="0" i="0">
                 <a:solidFill>
                   <a:srgbClr val="F7FBF8"/>
@@ -20519,6 +20850,7 @@
           </a:p>
           <a:p xmlns:a="http://schemas.openxmlformats.org/drawingml/2006/main">
             <a:pPr algn="l">
+              <a:buNone/>
               <a:defRPr sz="1200" b="0" i="0">
                 <a:solidFill>
                   <a:srgbClr val="F7FBF8"/>
@@ -20536,6 +20868,7 @@
           </a:p>
           <a:p xmlns:a="http://schemas.openxmlformats.org/drawingml/2006/main">
             <a:pPr algn="l">
+              <a:buNone/>
               <a:defRPr sz="1200" b="0" i="0">
                 <a:solidFill>
                   <a:srgbClr val="F7FBF8"/>
@@ -20553,6 +20886,7 @@
           </a:p>
           <a:p xmlns:a="http://schemas.openxmlformats.org/drawingml/2006/main">
             <a:pPr algn="l">
+              <a:buNone/>
               <a:defRPr sz="1200" b="0" i="0">
                 <a:solidFill>
                   <a:srgbClr val="F7FBF8"/>
@@ -20570,6 +20904,7 @@
           </a:p>
           <a:p xmlns:a="http://schemas.openxmlformats.org/drawingml/2006/main">
             <a:pPr algn="l">
+              <a:buNone/>
               <a:defRPr sz="1200" b="0" i="0">
                 <a:solidFill>
                   <a:srgbClr val="F7FBF8"/>
@@ -20587,6 +20922,7 @@
           </a:p>
           <a:p xmlns:a="http://schemas.openxmlformats.org/drawingml/2006/main">
             <a:pPr algn="l">
+              <a:buNone/>
               <a:defRPr sz="1200" b="0" i="0">
                 <a:solidFill>
                   <a:srgbClr val="F7FBF8"/>
@@ -20637,6 +20973,7 @@
           <a:lstStyle xmlns:a="http://schemas.openxmlformats.org/drawingml/2006/main"/>
           <a:p xmlns:a="http://schemas.openxmlformats.org/drawingml/2006/main">
             <a:pPr algn="l">
+              <a:buNone/>
               <a:defRPr sz="1800" b="1" i="0">
                 <a:solidFill>
                   <a:srgbClr val="159A64"/>
@@ -20687,6 +21024,7 @@
           <a:lstStyle xmlns:a="http://schemas.openxmlformats.org/drawingml/2006/main"/>
           <a:p xmlns:a="http://schemas.openxmlformats.org/drawingml/2006/main">
             <a:pPr algn="l">
+              <a:buNone/>
               <a:defRPr sz="1350" b="0" i="0">
                 <a:solidFill>
                   <a:srgbClr val="61786E"/>
@@ -20737,6 +21075,7 @@
           <a:lstStyle xmlns:a="http://schemas.openxmlformats.org/drawingml/2006/main"/>
           <a:p xmlns:a="http://schemas.openxmlformats.org/drawingml/2006/main">
             <a:pPr algn="l">
+              <a:buNone/>
               <a:defRPr sz="1500" b="0" i="0">
                 <a:solidFill>
                   <a:srgbClr val="163C2C"/>
@@ -20787,6 +21126,7 @@
           <a:lstStyle xmlns:a="http://schemas.openxmlformats.org/drawingml/2006/main"/>
           <a:p xmlns:a="http://schemas.openxmlformats.org/drawingml/2006/main">
             <a:pPr algn="l">
+              <a:buNone/>
               <a:defRPr sz="1350" b="0" i="0">
                 <a:solidFill>
                   <a:srgbClr val="61786E"/>
@@ -20837,6 +21177,7 @@
           <a:lstStyle xmlns:a="http://schemas.openxmlformats.org/drawingml/2006/main"/>
           <a:p xmlns:a="http://schemas.openxmlformats.org/drawingml/2006/main">
             <a:pPr algn="l">
+              <a:buNone/>
               <a:defRPr sz="1500" b="0" i="0">
                 <a:solidFill>
                   <a:srgbClr val="163C2C"/>
@@ -20887,6 +21228,7 @@
           <a:lstStyle xmlns:a="http://schemas.openxmlformats.org/drawingml/2006/main"/>
           <a:p xmlns:a="http://schemas.openxmlformats.org/drawingml/2006/main">
             <a:pPr algn="l">
+              <a:buNone/>
               <a:defRPr sz="1275" b="0" i="0">
                 <a:solidFill>
                   <a:srgbClr val="61786E"/>
@@ -20937,6 +21279,7 @@
           <a:lstStyle xmlns:a="http://schemas.openxmlformats.org/drawingml/2006/main"/>
           <a:p xmlns:a="http://schemas.openxmlformats.org/drawingml/2006/main">
             <a:pPr algn="l">
+              <a:buNone/>
               <a:defRPr sz="1425" b="0" i="0">
                 <a:solidFill>
                   <a:srgbClr val="163C2C"/>
@@ -21022,6 +21365,7 @@
           <a:lstStyle xmlns:a="http://schemas.openxmlformats.org/drawingml/2006/main"/>
           <a:p xmlns:a="http://schemas.openxmlformats.org/drawingml/2006/main">
             <a:pPr algn="l">
+              <a:buNone/>
               <a:defRPr sz="1275" b="1" i="0">
                 <a:solidFill>
                   <a:srgbClr val="48B985"/>
@@ -21134,6 +21478,7 @@
           <a:lstStyle xmlns:a="http://schemas.openxmlformats.org/drawingml/2006/main"/>
           <a:p xmlns:a="http://schemas.openxmlformats.org/drawingml/2006/main">
             <a:pPr algn="l">
+              <a:buNone/>
               <a:defRPr sz="1125" b="1" i="0">
                 <a:solidFill>
                   <a:srgbClr val="48B985"/>
@@ -21184,6 +21529,7 @@
           <a:lstStyle xmlns:a="http://schemas.openxmlformats.org/drawingml/2006/main"/>
           <a:p xmlns:a="http://schemas.openxmlformats.org/drawingml/2006/main">
             <a:pPr algn="l">
+              <a:buNone/>
               <a:defRPr sz="3150" b="1" i="0">
                 <a:solidFill>
                   <a:srgbClr val="163C2C"/>
@@ -21234,6 +21580,7 @@
           <a:lstStyle xmlns:a="http://schemas.openxmlformats.org/drawingml/2006/main"/>
           <a:p xmlns:a="http://schemas.openxmlformats.org/drawingml/2006/main">
             <a:pPr algn="l">
+              <a:buNone/>
               <a:defRPr sz="1500" b="0" i="0">
                 <a:solidFill>
                   <a:srgbClr val="61786E"/>
@@ -21315,6 +21662,7 @@
           <a:lstStyle xmlns:a="http://schemas.openxmlformats.org/drawingml/2006/main"/>
           <a:p xmlns:a="http://schemas.openxmlformats.org/drawingml/2006/main">
             <a:pPr algn="l">
+              <a:buNone/>
               <a:defRPr sz="900" b="1" i="0">
                 <a:solidFill>
                   <a:srgbClr val="7F9389"/>
@@ -21365,6 +21713,7 @@
           <a:lstStyle xmlns:a="http://schemas.openxmlformats.org/drawingml/2006/main"/>
           <a:p xmlns:a="http://schemas.openxmlformats.org/drawingml/2006/main">
             <a:pPr algn="r">
+              <a:buNone/>
               <a:defRPr sz="900" b="1" i="0">
                 <a:solidFill>
                   <a:srgbClr val="7F9389"/>
@@ -21415,6 +21764,7 @@
           <a:lstStyle xmlns:a="http://schemas.openxmlformats.org/drawingml/2006/main"/>
           <a:p xmlns:a="http://schemas.openxmlformats.org/drawingml/2006/main">
             <a:pPr algn="l">
+              <a:buNone/>
               <a:defRPr sz="1200" b="1" i="0">
                 <a:solidFill>
                   <a:srgbClr val="48B985"/>
@@ -21465,6 +21815,7 @@
           <a:lstStyle xmlns:a="http://schemas.openxmlformats.org/drawingml/2006/main"/>
           <a:p xmlns:a="http://schemas.openxmlformats.org/drawingml/2006/main">
             <a:pPr algn="l">
+              <a:buNone/>
               <a:defRPr sz="2250" b="1" i="0">
                 <a:solidFill>
                   <a:srgbClr val="163C2C"/>
@@ -21515,6 +21866,7 @@
           <a:lstStyle xmlns:a="http://schemas.openxmlformats.org/drawingml/2006/main"/>
           <a:p xmlns:a="http://schemas.openxmlformats.org/drawingml/2006/main">
             <a:pPr algn="l">
+              <a:buNone/>
               <a:defRPr sz="1200" b="1" i="0">
                 <a:solidFill>
                   <a:srgbClr val="159A64"/>
@@ -21565,6 +21917,7 @@
           <a:lstStyle xmlns:a="http://schemas.openxmlformats.org/drawingml/2006/main"/>
           <a:p xmlns:a="http://schemas.openxmlformats.org/drawingml/2006/main">
             <a:pPr algn="l">
+              <a:buNone/>
               <a:defRPr sz="2025" b="0" i="1">
                 <a:solidFill>
                   <a:srgbClr val="159A64"/>
@@ -21650,6 +22003,7 @@
           <a:lstStyle xmlns:a="http://schemas.openxmlformats.org/drawingml/2006/main"/>
           <a:p xmlns:a="http://schemas.openxmlformats.org/drawingml/2006/main">
             <a:pPr algn="l">
+              <a:buNone/>
               <a:defRPr sz="1200" b="1" i="0">
                 <a:solidFill>
                   <a:srgbClr val="7FA847"/>
@@ -21700,6 +22054,7 @@
           <a:lstStyle xmlns:a="http://schemas.openxmlformats.org/drawingml/2006/main"/>
           <a:p xmlns:a="http://schemas.openxmlformats.org/drawingml/2006/main">
             <a:pPr algn="l">
+              <a:buNone/>
               <a:defRPr sz="2100" b="1" i="0">
                 <a:solidFill>
                   <a:srgbClr val="48B985"/>
@@ -21750,6 +22105,7 @@
           <a:lstStyle xmlns:a="http://schemas.openxmlformats.org/drawingml/2006/main"/>
           <a:p xmlns:a="http://schemas.openxmlformats.org/drawingml/2006/main">
             <a:pPr algn="l">
+              <a:buNone/>
               <a:defRPr sz="1500" b="0" i="0">
                 <a:solidFill>
                   <a:srgbClr val="163C2C"/>
@@ -21800,6 +22156,7 @@
           <a:lstStyle xmlns:a="http://schemas.openxmlformats.org/drawingml/2006/main"/>
           <a:p xmlns:a="http://schemas.openxmlformats.org/drawingml/2006/main">
             <a:pPr algn="l">
+              <a:buNone/>
               <a:defRPr sz="2100" b="1" i="0">
                 <a:solidFill>
                   <a:srgbClr val="48B985"/>
@@ -21850,6 +22207,7 @@
           <a:lstStyle xmlns:a="http://schemas.openxmlformats.org/drawingml/2006/main"/>
           <a:p xmlns:a="http://schemas.openxmlformats.org/drawingml/2006/main">
             <a:pPr algn="l">
+              <a:buNone/>
               <a:defRPr sz="1500" b="0" i="0">
                 <a:solidFill>
                   <a:srgbClr val="163C2C"/>
@@ -21900,6 +22258,7 @@
           <a:lstStyle xmlns:a="http://schemas.openxmlformats.org/drawingml/2006/main"/>
           <a:p xmlns:a="http://schemas.openxmlformats.org/drawingml/2006/main">
             <a:pPr algn="l">
+              <a:buNone/>
               <a:defRPr sz="1500" b="1" i="0">
                 <a:solidFill>
                   <a:srgbClr val="61786E"/>
@@ -22012,6 +22371,7 @@
           <a:lstStyle xmlns:a="http://schemas.openxmlformats.org/drawingml/2006/main"/>
           <a:p xmlns:a="http://schemas.openxmlformats.org/drawingml/2006/main">
             <a:pPr algn="l">
+              <a:buNone/>
               <a:defRPr sz="1125" b="1" i="0">
                 <a:solidFill>
                   <a:srgbClr val="7FA847"/>
@@ -22062,6 +22422,7 @@
           <a:lstStyle xmlns:a="http://schemas.openxmlformats.org/drawingml/2006/main"/>
           <a:p xmlns:a="http://schemas.openxmlformats.org/drawingml/2006/main">
             <a:pPr algn="l">
+              <a:buNone/>
               <a:defRPr sz="3150" b="1" i="0">
                 <a:solidFill>
                   <a:srgbClr val="163C2C"/>
@@ -22112,6 +22473,7 @@
           <a:lstStyle xmlns:a="http://schemas.openxmlformats.org/drawingml/2006/main"/>
           <a:p xmlns:a="http://schemas.openxmlformats.org/drawingml/2006/main">
             <a:pPr algn="l">
+              <a:buNone/>
               <a:defRPr sz="1500" b="0" i="0">
                 <a:solidFill>
                   <a:srgbClr val="61786E"/>
@@ -22193,6 +22555,7 @@
           <a:lstStyle xmlns:a="http://schemas.openxmlformats.org/drawingml/2006/main"/>
           <a:p xmlns:a="http://schemas.openxmlformats.org/drawingml/2006/main">
             <a:pPr algn="l">
+              <a:buNone/>
               <a:defRPr sz="900" b="1" i="0">
                 <a:solidFill>
                   <a:srgbClr val="7F9389"/>
@@ -22243,6 +22606,7 @@
           <a:lstStyle xmlns:a="http://schemas.openxmlformats.org/drawingml/2006/main"/>
           <a:p xmlns:a="http://schemas.openxmlformats.org/drawingml/2006/main">
             <a:pPr algn="r">
+              <a:buNone/>
               <a:defRPr sz="900" b="1" i="0">
                 <a:solidFill>
                   <a:srgbClr val="7F9389"/>
@@ -22454,6 +22818,7 @@
           <a:lstStyle xmlns:a="http://schemas.openxmlformats.org/drawingml/2006/main"/>
           <a:p xmlns:a="http://schemas.openxmlformats.org/drawingml/2006/main">
             <a:pPr algn="l">
+              <a:buNone/>
               <a:defRPr sz="1200" b="0" i="0">
                 <a:solidFill>
                   <a:srgbClr val="F7FBF8"/>
@@ -22471,6 +22836,7 @@
           </a:p>
           <a:p xmlns:a="http://schemas.openxmlformats.org/drawingml/2006/main">
             <a:pPr algn="l">
+              <a:buNone/>
               <a:defRPr sz="1200" b="0" i="0">
                 <a:solidFill>
                   <a:srgbClr val="F7FBF8"/>
@@ -22488,6 +22854,7 @@
           </a:p>
           <a:p xmlns:a="http://schemas.openxmlformats.org/drawingml/2006/main">
             <a:pPr algn="l">
+              <a:buNone/>
               <a:defRPr sz="1200" b="0" i="0">
                 <a:solidFill>
                   <a:srgbClr val="F7FBF8"/>
@@ -22505,6 +22872,7 @@
           </a:p>
           <a:p xmlns:a="http://schemas.openxmlformats.org/drawingml/2006/main">
             <a:pPr algn="l">
+              <a:buNone/>
               <a:defRPr sz="1200" b="0" i="0">
                 <a:solidFill>
                   <a:srgbClr val="F7FBF8"/>
@@ -22522,6 +22890,7 @@
           </a:p>
           <a:p xmlns:a="http://schemas.openxmlformats.org/drawingml/2006/main">
             <a:pPr algn="l">
+              <a:buNone/>
               <a:defRPr sz="1200" b="0" i="0">
                 <a:solidFill>
                   <a:srgbClr val="F7FBF8"/>
@@ -22539,6 +22908,7 @@
           </a:p>
           <a:p xmlns:a="http://schemas.openxmlformats.org/drawingml/2006/main">
             <a:pPr algn="l">
+              <a:buNone/>
               <a:defRPr sz="1200" b="0" i="0">
                 <a:solidFill>
                   <a:srgbClr val="F7FBF8"/>
@@ -22556,6 +22926,7 @@
           </a:p>
           <a:p xmlns:a="http://schemas.openxmlformats.org/drawingml/2006/main">
             <a:pPr algn="l">
+              <a:buNone/>
               <a:defRPr sz="1200" b="0" i="0">
                 <a:solidFill>
                   <a:srgbClr val="F7FBF8"/>
@@ -22573,6 +22944,7 @@
           </a:p>
           <a:p xmlns:a="http://schemas.openxmlformats.org/drawingml/2006/main">
             <a:pPr algn="l">
+              <a:buNone/>
               <a:defRPr sz="1200" b="0" i="0">
                 <a:solidFill>
                   <a:srgbClr val="F7FBF8"/>
@@ -22590,6 +22962,7 @@
           </a:p>
           <a:p xmlns:a="http://schemas.openxmlformats.org/drawingml/2006/main">
             <a:pPr algn="l">
+              <a:buNone/>
               <a:defRPr sz="1200" b="0" i="0">
                 <a:solidFill>
                   <a:srgbClr val="F7FBF8"/>
@@ -22640,6 +23013,7 @@
           <a:lstStyle xmlns:a="http://schemas.openxmlformats.org/drawingml/2006/main"/>
           <a:p xmlns:a="http://schemas.openxmlformats.org/drawingml/2006/main">
             <a:pPr algn="l">
+              <a:buNone/>
               <a:defRPr sz="1200" b="1" i="0">
                 <a:solidFill>
                   <a:srgbClr val="48B985"/>
@@ -22851,6 +23225,7 @@
           <a:lstStyle xmlns:a="http://schemas.openxmlformats.org/drawingml/2006/main"/>
           <a:p xmlns:a="http://schemas.openxmlformats.org/drawingml/2006/main">
             <a:pPr algn="l">
+              <a:buNone/>
               <a:defRPr sz="1200" b="0" i="0">
                 <a:solidFill>
                   <a:srgbClr val="F7FBF8"/>
@@ -22868,6 +23243,7 @@
           </a:p>
           <a:p xmlns:a="http://schemas.openxmlformats.org/drawingml/2006/main">
             <a:pPr algn="l">
+              <a:buNone/>
               <a:defRPr sz="1200" b="0" i="0">
                 <a:solidFill>
                   <a:srgbClr val="F7FBF8"/>
@@ -22885,6 +23261,7 @@
           </a:p>
           <a:p xmlns:a="http://schemas.openxmlformats.org/drawingml/2006/main">
             <a:pPr algn="l">
+              <a:buNone/>
               <a:defRPr sz="1200" b="0" i="0">
                 <a:solidFill>
                   <a:srgbClr val="F7FBF8"/>
@@ -22902,6 +23279,7 @@
           </a:p>
           <a:p xmlns:a="http://schemas.openxmlformats.org/drawingml/2006/main">
             <a:pPr algn="l">
+              <a:buNone/>
               <a:defRPr sz="1200" b="0" i="0">
                 <a:solidFill>
                   <a:srgbClr val="F7FBF8"/>
@@ -22919,6 +23297,7 @@
           </a:p>
           <a:p xmlns:a="http://schemas.openxmlformats.org/drawingml/2006/main">
             <a:pPr algn="l">
+              <a:buNone/>
               <a:defRPr sz="1200" b="0" i="0">
                 <a:solidFill>
                   <a:srgbClr val="F7FBF8"/>
@@ -22936,6 +23315,7 @@
           </a:p>
           <a:p xmlns:a="http://schemas.openxmlformats.org/drawingml/2006/main">
             <a:pPr algn="l">
+              <a:buNone/>
               <a:defRPr sz="1200" b="0" i="0">
                 <a:solidFill>
                   <a:srgbClr val="F7FBF8"/>
@@ -22953,6 +23333,7 @@
           </a:p>
           <a:p xmlns:a="http://schemas.openxmlformats.org/drawingml/2006/main">
             <a:pPr algn="l">
+              <a:buNone/>
               <a:defRPr sz="1200" b="0" i="0">
                 <a:solidFill>
                   <a:srgbClr val="F7FBF8"/>
@@ -22970,6 +23351,7 @@
           </a:p>
           <a:p xmlns:a="http://schemas.openxmlformats.org/drawingml/2006/main">
             <a:pPr algn="l">
+              <a:buNone/>
               <a:defRPr sz="1200" b="0" i="0">
                 <a:solidFill>
                   <a:srgbClr val="F7FBF8"/>
@@ -23055,6 +23437,7 @@
           <a:lstStyle xmlns:a="http://schemas.openxmlformats.org/drawingml/2006/main"/>
           <a:p xmlns:a="http://schemas.openxmlformats.org/drawingml/2006/main">
             <a:pPr algn="ctr">
+              <a:buNone/>
               <a:defRPr sz="1500" b="1" i="0">
                 <a:solidFill>
                   <a:srgbClr val="163C2C"/>
@@ -23167,6 +23550,7 @@
           <a:lstStyle xmlns:a="http://schemas.openxmlformats.org/drawingml/2006/main"/>
           <a:p xmlns:a="http://schemas.openxmlformats.org/drawingml/2006/main">
             <a:pPr algn="l">
+              <a:buNone/>
               <a:defRPr sz="1125" b="1" i="0">
                 <a:solidFill>
                   <a:srgbClr val="48B985"/>
@@ -23217,6 +23601,7 @@
           <a:lstStyle xmlns:a="http://schemas.openxmlformats.org/drawingml/2006/main"/>
           <a:p xmlns:a="http://schemas.openxmlformats.org/drawingml/2006/main">
             <a:pPr algn="l">
+              <a:buNone/>
               <a:defRPr sz="3150" b="1" i="0">
                 <a:solidFill>
                   <a:srgbClr val="163C2C"/>
@@ -23267,6 +23652,7 @@
           <a:lstStyle xmlns:a="http://schemas.openxmlformats.org/drawingml/2006/main"/>
           <a:p xmlns:a="http://schemas.openxmlformats.org/drawingml/2006/main">
             <a:pPr algn="l">
+              <a:buNone/>
               <a:defRPr sz="1500" b="0" i="0">
                 <a:solidFill>
                   <a:srgbClr val="61786E"/>
@@ -23348,6 +23734,7 @@
           <a:lstStyle xmlns:a="http://schemas.openxmlformats.org/drawingml/2006/main"/>
           <a:p xmlns:a="http://schemas.openxmlformats.org/drawingml/2006/main">
             <a:pPr algn="l">
+              <a:buNone/>
               <a:defRPr sz="900" b="1" i="0">
                 <a:solidFill>
                   <a:srgbClr val="7F9389"/>
@@ -23398,6 +23785,7 @@
           <a:lstStyle xmlns:a="http://schemas.openxmlformats.org/drawingml/2006/main"/>
           <a:p xmlns:a="http://schemas.openxmlformats.org/drawingml/2006/main">
             <a:pPr algn="r">
+              <a:buNone/>
               <a:defRPr sz="900" b="1" i="0">
                 <a:solidFill>
                   <a:srgbClr val="7F9389"/>
@@ -23483,6 +23871,7 @@
           <a:lstStyle xmlns:a="http://schemas.openxmlformats.org/drawingml/2006/main"/>
           <a:p xmlns:a="http://schemas.openxmlformats.org/drawingml/2006/main">
             <a:pPr algn="l">
+              <a:buNone/>
               <a:defRPr sz="1200" b="1" i="0">
                 <a:solidFill>
                   <a:srgbClr val="6FAF8D"/>
@@ -23533,6 +23922,7 @@
           <a:lstStyle xmlns:a="http://schemas.openxmlformats.org/drawingml/2006/main"/>
           <a:p xmlns:a="http://schemas.openxmlformats.org/drawingml/2006/main">
             <a:pPr algn="l">
+              <a:buNone/>
               <a:defRPr sz="1725" b="0" i="0">
                 <a:solidFill>
                   <a:srgbClr val="163C2C"/>
@@ -23550,6 +23940,7 @@
           </a:p>
           <a:p xmlns:a="http://schemas.openxmlformats.org/drawingml/2006/main">
             <a:pPr algn="l">
+              <a:buNone/>
               <a:defRPr sz="1725" b="0" i="0">
                 <a:solidFill>
                   <a:srgbClr val="163C2C"/>
@@ -23567,6 +23958,7 @@
           </a:p>
           <a:p xmlns:a="http://schemas.openxmlformats.org/drawingml/2006/main">
             <a:pPr algn="l">
+              <a:buNone/>
               <a:defRPr sz="1725" b="0" i="0">
                 <a:solidFill>
                   <a:srgbClr val="163C2C"/>
@@ -23584,6 +23976,7 @@
           </a:p>
           <a:p xmlns:a="http://schemas.openxmlformats.org/drawingml/2006/main">
             <a:pPr algn="l">
+              <a:buNone/>
               <a:defRPr sz="1725" b="0" i="0">
                 <a:solidFill>
                   <a:srgbClr val="163C2C"/>
@@ -23665,6 +24058,7 @@
           <a:lstStyle xmlns:a="http://schemas.openxmlformats.org/drawingml/2006/main"/>
           <a:p xmlns:a="http://schemas.openxmlformats.org/drawingml/2006/main">
             <a:pPr algn="ctr">
+              <a:buNone/>
               <a:defRPr sz="2250" b="1" i="0">
                 <a:solidFill>
                   <a:srgbClr val="F7FBF8"/>
@@ -24375,6 +24769,7 @@
           <a:lstStyle xmlns:a="http://schemas.openxmlformats.org/drawingml/2006/main"/>
           <a:p xmlns:a="http://schemas.openxmlformats.org/drawingml/2006/main">
             <a:pPr algn="ctr">
+              <a:buNone/>
               <a:defRPr sz="1800" b="1" i="0">
                 <a:solidFill>
                   <a:srgbClr val="163C2C"/>

</xml_diff>